<commit_message>
Add 1–2 threshold alerts per mall to Parque Arauco fichas
Each recinto ficha now proposes the one or two most important WES
threshold alerts for the meeting. Daily = operational average × 1.25;
night = m³ 00:00–06:00. No night threshold on points that already have
control. A closing slide lists all seven malls for the room.

Co-authored-by: anibaloperacionesWes <anibaloperacionesWes@users.noreply.github.com>
</commit_message>
<xml_diff>
--- a/reports/Parque_Arauco/TMP_7MALLS/entrega_diego_anibal/Fichas_ejecutivas_Parque_Arauco_20260816.pptx
+++ b/reports/Parque_Arauco/TMP_7MALLS/entrega_diego_anibal/Fichas_ejecutivas_Parque_Arauco_20260816.pptx
@@ -15,6 +15,7 @@
     <p:sldId id="263" r:id="rId14"/>
     <p:sldId id="264" r:id="rId15"/>
     <p:sldId id="265" r:id="rId16"/>
+    <p:sldId id="266" r:id="rId17"/>
   </p:sldIdLst>
   <p:sldSz cx="12191695" cy="6858000" type="screen4x3"/>
   <p:notesSz cx="6858000" cy="9144000"/>
@@ -3292,7 +3293,7 @@
                 </a:solidFill>
                 <a:latin typeface="Calibri"/>
               </a:rPr>
-              <a:t>5 variables por mall  ·  si hay control nocturno, esa madrugada no se lee como fuga</a:t>
+              <a:t>6 variables por mall  ·  umbrales a proponer en reunión  ·  noche con control ≠ fuga</a:t>
             </a:r>
           </a:p>
           <a:p>
@@ -4957,6 +4958,1063 @@
 </p:sld>
 </file>
 
+<file path=ppt/slides/slide11.xml><?xml version="1.0" encoding="utf-8"?>
+<p:sld xmlns:a="http://schemas.openxmlformats.org/drawingml/2006/main" xmlns:p="http://schemas.openxmlformats.org/presentationml/2006/main" xmlns:r="http://schemas.openxmlformats.org/officeDocument/2006/relationships">
+  <p:cSld>
+    <p:spTree>
+      <p:nvGrpSpPr>
+        <p:cNvPr id="1" name=""/>
+        <p:cNvGrpSpPr/>
+        <p:nvPr/>
+      </p:nvGrpSpPr>
+      <p:grpSpPr/>
+      <p:sp>
+        <p:nvSpPr>
+          <p:cNvPr id="2" name="Rectangle 1"/>
+          <p:cNvSpPr/>
+          <p:nvPr/>
+        </p:nvSpPr>
+        <p:spPr>
+          <a:xfrm>
+            <a:off x="0" y="0"/>
+            <a:ext cx="12191695" cy="841248"/>
+          </a:xfrm>
+          <a:prstGeom prst="rect">
+            <a:avLst/>
+          </a:prstGeom>
+          <a:solidFill>
+            <a:srgbClr val="0D3B66"/>
+          </a:solidFill>
+          <a:ln>
+            <a:noFill/>
+          </a:ln>
+        </p:spPr>
+        <p:style>
+          <a:lnRef idx="1">
+            <a:schemeClr val="accent1"/>
+          </a:lnRef>
+          <a:fillRef idx="3">
+            <a:schemeClr val="accent1"/>
+          </a:fillRef>
+          <a:effectRef idx="2">
+            <a:schemeClr val="accent1"/>
+          </a:effectRef>
+          <a:fontRef idx="minor">
+            <a:schemeClr val="lt1"/>
+          </a:fontRef>
+        </p:style>
+        <p:txBody>
+          <a:bodyPr rtlCol="0" anchor="ctr"/>
+          <a:lstStyle/>
+          <a:p>
+            <a:pPr algn="ctr"/>
+          </a:p>
+        </p:txBody>
+      </p:sp>
+      <p:sp>
+        <p:nvSpPr>
+          <p:cNvPr id="3" name="Rectangle 2"/>
+          <p:cNvSpPr/>
+          <p:nvPr/>
+        </p:nvSpPr>
+        <p:spPr>
+          <a:xfrm>
+            <a:off x="0" y="841248"/>
+            <a:ext cx="12191695" cy="54864"/>
+          </a:xfrm>
+          <a:prstGeom prst="rect">
+            <a:avLst/>
+          </a:prstGeom>
+          <a:solidFill>
+            <a:srgbClr val="C9A227"/>
+          </a:solidFill>
+          <a:ln>
+            <a:noFill/>
+          </a:ln>
+        </p:spPr>
+        <p:style>
+          <a:lnRef idx="1">
+            <a:schemeClr val="accent1"/>
+          </a:lnRef>
+          <a:fillRef idx="3">
+            <a:schemeClr val="accent1"/>
+          </a:fillRef>
+          <a:effectRef idx="2">
+            <a:schemeClr val="accent1"/>
+          </a:effectRef>
+          <a:fontRef idx="minor">
+            <a:schemeClr val="lt1"/>
+          </a:fontRef>
+        </p:style>
+        <p:txBody>
+          <a:bodyPr rtlCol="0" anchor="ctr"/>
+          <a:lstStyle/>
+          <a:p>
+            <a:pPr algn="ctr"/>
+          </a:p>
+        </p:txBody>
+      </p:sp>
+      <p:pic>
+        <p:nvPicPr>
+          <p:cNvPr id="4" name="Picture 3" descr="logo wes.bmp"/>
+          <p:cNvPicPr>
+            <a:picLocks noChangeAspect="1"/>
+          </p:cNvPicPr>
+          <p:nvPr/>
+        </p:nvPicPr>
+        <p:blipFill>
+          <a:blip r:embed="rId2"/>
+          <a:stretch>
+            <a:fillRect/>
+          </a:stretch>
+        </p:blipFill>
+        <p:spPr>
+          <a:xfrm>
+            <a:off x="11109960" y="164592"/>
+            <a:ext cx="2392226" cy="530352"/>
+          </a:xfrm>
+          <a:prstGeom prst="rect">
+            <a:avLst/>
+          </a:prstGeom>
+        </p:spPr>
+      </p:pic>
+      <p:sp>
+        <p:nvSpPr>
+          <p:cNvPr id="5" name="TextBox 4"/>
+          <p:cNvSpPr txBox="1"/>
+          <p:nvPr/>
+        </p:nvSpPr>
+        <p:spPr>
+          <a:xfrm>
+            <a:off x="256032" y="109728"/>
+            <a:ext cx="10607040" cy="384048"/>
+          </a:xfrm>
+          <a:prstGeom prst="rect">
+            <a:avLst/>
+          </a:prstGeom>
+          <a:noFill/>
+        </p:spPr>
+        <p:txBody>
+          <a:bodyPr wrap="square">
+            <a:spAutoFit/>
+          </a:bodyPr>
+          <a:lstStyle/>
+          <a:p>
+            <a:pPr algn="l">
+              <a:spcAft>
+                <a:spcPts val="200"/>
+              </a:spcAft>
+            </a:pPr>
+            <a:r>
+              <a:rPr sz="2000" b="1">
+                <a:solidFill>
+                  <a:srgbClr val="FFFFFF"/>
+                </a:solidFill>
+                <a:latin typeface="Calibri"/>
+              </a:rPr>
+              <a:t>Para la reunión  ·  umbrales a cargar en WES</a:t>
+            </a:r>
+          </a:p>
+        </p:txBody>
+      </p:sp>
+      <p:sp>
+        <p:nvSpPr>
+          <p:cNvPr id="6" name="TextBox 5"/>
+          <p:cNvSpPr txBox="1"/>
+          <p:nvPr/>
+        </p:nvSpPr>
+        <p:spPr>
+          <a:xfrm>
+            <a:off x="256032" y="457200"/>
+            <a:ext cx="10607040" cy="329184"/>
+          </a:xfrm>
+          <a:prstGeom prst="rect">
+            <a:avLst/>
+          </a:prstGeom>
+          <a:noFill/>
+        </p:spPr>
+        <p:txBody>
+          <a:bodyPr wrap="square">
+            <a:spAutoFit/>
+          </a:bodyPr>
+          <a:lstStyle/>
+          <a:p>
+            <a:pPr algn="l">
+              <a:spcAft>
+                <a:spcPts val="200"/>
+              </a:spcAft>
+            </a:pPr>
+            <a:r>
+              <a:rPr sz="1100" b="0">
+                <a:solidFill>
+                  <a:srgbClr val="DCE6F0"/>
+                </a:solidFill>
+                <a:latin typeface="Calibri"/>
+              </a:rPr>
+              <a:t>1 o 2 por mall. Diario = promedio operativo × 1,25. Nocturno = m³ 00:00–06:00. Sin umbral de madrugada si ya hay control.</a:t>
+            </a:r>
+          </a:p>
+        </p:txBody>
+      </p:sp>
+      <p:graphicFrame>
+        <p:nvGraphicFramePr>
+          <p:cNvPr id="7" name="Table 6"/>
+          <p:cNvGraphicFramePr>
+            <a:graphicFrameLocks noGrp="1"/>
+          </p:cNvGraphicFramePr>
+          <p:nvPr/>
+        </p:nvGraphicFramePr>
+        <p:xfrm>
+          <a:off x="256032" y="1078992"/>
+          <a:ext cx="11658600" cy="5074920"/>
+        </p:xfrm>
+        <a:graphic>
+          <a:graphicData uri="http://schemas.openxmlformats.org/drawingml/2006/table">
+            <a:tbl>
+              <a:tblPr firstRow="1" bandRow="1">
+                <a:tableStyleId>{5C22544A-7EE6-4342-B048-85BDC9FD1C3A}</a:tableStyleId>
+              </a:tblPr>
+              <a:tblGrid>
+                <a:gridCol w="1691640"/>
+                <a:gridCol w="3794760"/>
+                <a:gridCol w="3794760"/>
+                <a:gridCol w="2377440"/>
+              </a:tblGrid>
+              <a:tr h="634365">
+                <a:tc>
+                  <a:txBody>
+                    <a:bodyPr/>
+                    <a:lstStyle/>
+                    <a:p>
+                      <a:pPr>
+                        <a:defRPr sz="1100" b="1">
+                          <a:solidFill>
+                            <a:srgbClr val="FFFFFF"/>
+                          </a:solidFill>
+                          <a:latin typeface="Calibri"/>
+                        </a:defRPr>
+                      </a:pPr>
+                      <a:r>
+                        <a:t>Mall</a:t>
+                      </a:r>
+                    </a:p>
+                  </a:txBody>
+                  <a:tcPr>
+                    <a:solidFill>
+                      <a:srgbClr val="0D3B66"/>
+                    </a:solidFill>
+                  </a:tcPr>
+                </a:tc>
+                <a:tc>
+                  <a:txBody>
+                    <a:bodyPr/>
+                    <a:lstStyle/>
+                    <a:p>
+                      <a:pPr>
+                        <a:defRPr sz="1100" b="1">
+                          <a:solidFill>
+                            <a:srgbClr val="FFFFFF"/>
+                          </a:solidFill>
+                          <a:latin typeface="Calibri"/>
+                        </a:defRPr>
+                      </a:pPr>
+                      <a:r>
+                        <a:t>Umbral 1 (prioridad)</a:t>
+                      </a:r>
+                    </a:p>
+                  </a:txBody>
+                  <a:tcPr>
+                    <a:solidFill>
+                      <a:srgbClr val="0D3B66"/>
+                    </a:solidFill>
+                  </a:tcPr>
+                </a:tc>
+                <a:tc>
+                  <a:txBody>
+                    <a:bodyPr/>
+                    <a:lstStyle/>
+                    <a:p>
+                      <a:pPr>
+                        <a:defRPr sz="1100" b="1">
+                          <a:solidFill>
+                            <a:srgbClr val="FFFFFF"/>
+                          </a:solidFill>
+                          <a:latin typeface="Calibri"/>
+                        </a:defRPr>
+                      </a:pPr>
+                      <a:r>
+                        <a:t>Umbral 2</a:t>
+                      </a:r>
+                    </a:p>
+                  </a:txBody>
+                  <a:tcPr>
+                    <a:solidFill>
+                      <a:srgbClr val="0D3B66"/>
+                    </a:solidFill>
+                  </a:tcPr>
+                </a:tc>
+                <a:tc>
+                  <a:txBody>
+                    <a:bodyPr/>
+                    <a:lstStyle/>
+                    <a:p>
+                      <a:pPr>
+                        <a:defRPr sz="1100" b="1">
+                          <a:solidFill>
+                            <a:srgbClr val="FFFFFF"/>
+                          </a:solidFill>
+                          <a:latin typeface="Calibri"/>
+                        </a:defRPr>
+                      </a:pPr>
+                      <a:r>
+                        <a:t>Por qué este corte</a:t>
+                      </a:r>
+                    </a:p>
+                  </a:txBody>
+                  <a:tcPr>
+                    <a:solidFill>
+                      <a:srgbClr val="0D3B66"/>
+                    </a:solidFill>
+                  </a:tcPr>
+                </a:tc>
+              </a:tr>
+              <a:tr h="634365">
+                <a:tc>
+                  <a:txBody>
+                    <a:bodyPr/>
+                    <a:lstStyle/>
+                    <a:p>
+                      <a:pPr>
+                        <a:defRPr sz="1000" b="1">
+                          <a:solidFill>
+                            <a:srgbClr val="0D3B66"/>
+                          </a:solidFill>
+                          <a:latin typeface="Calibri"/>
+                        </a:defRPr>
+                      </a:pPr>
+                      <a:r>
+                        <a:t>MAE Estación</a:t>
+                      </a:r>
+                    </a:p>
+                  </a:txBody>
+                  <a:tcPr>
+                    <a:solidFill>
+                      <a:srgbClr val="F5F7FA"/>
+                    </a:solidFill>
+                  </a:tcPr>
+                </a:tc>
+                <a:tc>
+                  <a:txBody>
+                    <a:bodyPr/>
+                    <a:lstStyle/>
+                    <a:p>
+                      <a:pPr>
+                        <a:defRPr sz="1000" b="0">
+                          <a:solidFill>
+                            <a:srgbClr val="0D3B66"/>
+                          </a:solidFill>
+                          <a:latin typeface="Calibri"/>
+                        </a:defRPr>
+                      </a:pPr>
+                      <a:r>
+                        <a:t>Diario · Estanque Norte (01): 40 m³/día</a:t>
+                      </a:r>
+                    </a:p>
+                  </a:txBody>
+                  <a:tcPr>
+                    <a:solidFill>
+                      <a:srgbClr val="F5F7FA"/>
+                    </a:solidFill>
+                  </a:tcPr>
+                </a:tc>
+                <a:tc>
+                  <a:txBody>
+                    <a:bodyPr/>
+                    <a:lstStyle/>
+                    <a:p>
+                      <a:pPr>
+                        <a:defRPr sz="1000" b="0">
+                          <a:solidFill>
+                            <a:srgbClr val="0D3B66"/>
+                          </a:solidFill>
+                          <a:latin typeface="Calibri"/>
+                        </a:defRPr>
+                      </a:pPr>
+                      <a:r>
+                        <a:t>Diario · Pizza Hut (07): 25 m³/día</a:t>
+                      </a:r>
+                    </a:p>
+                  </a:txBody>
+                  <a:tcPr>
+                    <a:solidFill>
+                      <a:srgbClr val="F5F7FA"/>
+                    </a:solidFill>
+                  </a:tcPr>
+                </a:tc>
+                <a:tc>
+                  <a:txBody>
+                    <a:bodyPr/>
+                    <a:lstStyle/>
+                    <a:p>
+                      <a:pPr>
+                        <a:defRPr sz="1000" b="0">
+                          <a:solidFill>
+                            <a:srgbClr val="0D3B66"/>
+                          </a:solidFill>
+                          <a:latin typeface="Calibri"/>
+                        </a:defRPr>
+                      </a:pPr>
+                      <a:r>
+                        <a:t>Alza diurna ago; noche ya controlada</a:t>
+                      </a:r>
+                    </a:p>
+                  </a:txBody>
+                  <a:tcPr>
+                    <a:solidFill>
+                      <a:srgbClr val="F5F7FA"/>
+                    </a:solidFill>
+                  </a:tcPr>
+                </a:tc>
+              </a:tr>
+              <a:tr h="634365">
+                <a:tc>
+                  <a:txBody>
+                    <a:bodyPr/>
+                    <a:lstStyle/>
+                    <a:p>
+                      <a:pPr>
+                        <a:defRPr sz="1000" b="1">
+                          <a:solidFill>
+                            <a:srgbClr val="0D3B66"/>
+                          </a:solidFill>
+                          <a:latin typeface="Calibri"/>
+                        </a:defRPr>
+                      </a:pPr>
+                      <a:r>
+                        <a:t>MAM Maipú</a:t>
+                      </a:r>
+                    </a:p>
+                  </a:txBody>
+                  <a:tcPr>
+                    <a:solidFill>
+                      <a:srgbClr val="FFFFFF"/>
+                    </a:solidFill>
+                  </a:tcPr>
+                </a:tc>
+                <a:tc>
+                  <a:txBody>
+                    <a:bodyPr/>
+                    <a:lstStyle/>
+                    <a:p>
+                      <a:pPr>
+                        <a:defRPr sz="1000" b="0">
+                          <a:solidFill>
+                            <a:srgbClr val="0D3B66"/>
+                          </a:solidFill>
+                          <a:latin typeface="Calibri"/>
+                        </a:defRPr>
+                      </a:pPr>
+                      <a:r>
+                        <a:t>Diario · Placa Bancaria (08): 155 m³/día</a:t>
+                      </a:r>
+                    </a:p>
+                  </a:txBody>
+                  <a:tcPr>
+                    <a:solidFill>
+                      <a:srgbClr val="FFFFFF"/>
+                    </a:solidFill>
+                  </a:tcPr>
+                </a:tc>
+                <a:tc>
+                  <a:txBody>
+                    <a:bodyPr/>
+                    <a:lstStyle/>
+                    <a:p>
+                      <a:pPr>
+                        <a:defRPr sz="1000" b="0">
+                          <a:solidFill>
+                            <a:srgbClr val="0D3B66"/>
+                          </a:solidFill>
+                          <a:latin typeface="Calibri"/>
+                        </a:defRPr>
+                      </a:pPr>
+                      <a:r>
+                        <a:t>Diario · Ripley (10): 125 m³/día</a:t>
+                      </a:r>
+                    </a:p>
+                  </a:txBody>
+                  <a:tcPr>
+                    <a:solidFill>
+                      <a:srgbClr val="FFFFFF"/>
+                    </a:solidFill>
+                  </a:tcPr>
+                </a:tc>
+                <a:tc>
+                  <a:txBody>
+                    <a:bodyPr/>
+                    <a:lstStyle/>
+                    <a:p>
+                      <a:pPr>
+                        <a:defRPr sz="1000" b="0">
+                          <a:solidFill>
+                            <a:srgbClr val="0D3B66"/>
+                          </a:solidFill>
+                          <a:latin typeface="Calibri"/>
+                        </a:defRPr>
+                      </a:pPr>
+                      <a:r>
+                        <a:t>Atrapa otro 18/06 (~410) sin media inflada</a:t>
+                      </a:r>
+                    </a:p>
+                  </a:txBody>
+                  <a:tcPr>
+                    <a:solidFill>
+                      <a:srgbClr val="FFFFFF"/>
+                    </a:solidFill>
+                  </a:tcPr>
+                </a:tc>
+              </a:tr>
+              <a:tr h="634365">
+                <a:tc>
+                  <a:txBody>
+                    <a:bodyPr/>
+                    <a:lstStyle/>
+                    <a:p>
+                      <a:pPr>
+                        <a:defRPr sz="1000" b="1">
+                          <a:solidFill>
+                            <a:srgbClr val="0D3B66"/>
+                          </a:solidFill>
+                          <a:latin typeface="Calibri"/>
+                        </a:defRPr>
+                      </a:pPr>
+                      <a:r>
+                        <a:t>MAQ Quilicura</a:t>
+                      </a:r>
+                    </a:p>
+                  </a:txBody>
+                  <a:tcPr>
+                    <a:solidFill>
+                      <a:srgbClr val="F5F7FA"/>
+                    </a:solidFill>
+                  </a:tcPr>
+                </a:tc>
+                <a:tc>
+                  <a:txBody>
+                    <a:bodyPr/>
+                    <a:lstStyle/>
+                    <a:p>
+                      <a:pPr>
+                        <a:defRPr sz="1000" b="0">
+                          <a:solidFill>
+                            <a:srgbClr val="0D3B66"/>
+                          </a:solidFill>
+                          <a:latin typeface="Calibri"/>
+                        </a:defRPr>
+                      </a:pPr>
+                      <a:r>
+                        <a:t>Nocturno · Matriz Principal (13): &gt; 8 m³ 00–06 h</a:t>
+                      </a:r>
+                    </a:p>
+                  </a:txBody>
+                  <a:tcPr>
+                    <a:solidFill>
+                      <a:srgbClr val="F5F7FA"/>
+                    </a:solidFill>
+                  </a:tcPr>
+                </a:tc>
+                <a:tc>
+                  <a:txBody>
+                    <a:bodyPr/>
+                    <a:lstStyle/>
+                    <a:p>
+                      <a:pPr>
+                        <a:defRPr sz="1000" b="0">
+                          <a:solidFill>
+                            <a:srgbClr val="0D3B66"/>
+                          </a:solidFill>
+                          <a:latin typeface="Calibri"/>
+                        </a:defRPr>
+                      </a:pPr>
+                      <a:r>
+                        <a:t>Diario · Matriz Principal (13): 230 m³/día</a:t>
+                      </a:r>
+                    </a:p>
+                  </a:txBody>
+                  <a:tcPr>
+                    <a:solidFill>
+                      <a:srgbClr val="F5F7FA"/>
+                    </a:solidFill>
+                  </a:tcPr>
+                </a:tc>
+                <a:tc>
+                  <a:txBody>
+                    <a:bodyPr/>
+                    <a:lstStyle/>
+                    <a:p>
+                      <a:pPr>
+                        <a:defRPr sz="1000" b="0">
+                          <a:solidFill>
+                            <a:srgbClr val="0D3B66"/>
+                          </a:solidFill>
+                          <a:latin typeface="Calibri"/>
+                        </a:defRPr>
+                      </a:pPr>
+                      <a:r>
+                        <a:t>Hoy 21–26 m³; sin on/off</a:t>
+                      </a:r>
+                    </a:p>
+                  </a:txBody>
+                  <a:tcPr>
+                    <a:solidFill>
+                      <a:srgbClr val="F5F7FA"/>
+                    </a:solidFill>
+                  </a:tcPr>
+                </a:tc>
+              </a:tr>
+              <a:tr h="634365">
+                <a:tc>
+                  <a:txBody>
+                    <a:bodyPr/>
+                    <a:lstStyle/>
+                    <a:p>
+                      <a:pPr>
+                        <a:defRPr sz="1000" b="1">
+                          <a:solidFill>
+                            <a:srgbClr val="0D3B66"/>
+                          </a:solidFill>
+                          <a:latin typeface="Calibri"/>
+                        </a:defRPr>
+                      </a:pPr>
+                      <a:r>
+                        <a:t>BOM Buenaventura</a:t>
+                      </a:r>
+                    </a:p>
+                  </a:txBody>
+                  <a:tcPr>
+                    <a:solidFill>
+                      <a:srgbClr val="FFFFFF"/>
+                    </a:solidFill>
+                  </a:tcPr>
+                </a:tc>
+                <a:tc>
+                  <a:txBody>
+                    <a:bodyPr/>
+                    <a:lstStyle/>
+                    <a:p>
+                      <a:pPr>
+                        <a:defRPr sz="1000" b="0">
+                          <a:solidFill>
+                            <a:srgbClr val="0D3B66"/>
+                          </a:solidFill>
+                          <a:latin typeface="Calibri"/>
+                        </a:defRPr>
+                      </a:pPr>
+                      <a:r>
+                        <a:t>Diario · San Ignacio 500 (18): 145 m³/día</a:t>
+                      </a:r>
+                    </a:p>
+                  </a:txBody>
+                  <a:tcPr>
+                    <a:solidFill>
+                      <a:srgbClr val="FFFFFF"/>
+                    </a:solidFill>
+                  </a:tcPr>
+                </a:tc>
+                <a:tc>
+                  <a:txBody>
+                    <a:bodyPr/>
+                    <a:lstStyle/>
+                    <a:p>
+                      <a:pPr>
+                        <a:defRPr sz="1000" b="0">
+                          <a:solidFill>
+                            <a:srgbClr val="0D3B66"/>
+                          </a:solidFill>
+                          <a:latin typeface="Calibri"/>
+                        </a:defRPr>
+                      </a:pPr>
+                      <a:r>
+                        <a:t>Nocturno · San Ignacio 300 (17): &gt; 4 m³ 00–06 h</a:t>
+                      </a:r>
+                    </a:p>
+                  </a:txBody>
+                  <a:tcPr>
+                    <a:solidFill>
+                      <a:srgbClr val="FFFFFF"/>
+                    </a:solidFill>
+                  </a:tcPr>
+                </a:tc>
+                <a:tc>
+                  <a:txBody>
+                    <a:bodyPr/>
+                    <a:lstStyle/>
+                    <a:p>
+                      <a:pPr>
+                        <a:defRPr sz="1000" b="0">
+                          <a:solidFill>
+                            <a:srgbClr val="0D3B66"/>
+                          </a:solidFill>
+                          <a:latin typeface="Calibri"/>
+                        </a:defRPr>
+                      </a:pPr>
+                      <a:r>
+                        <a:t>Noche ya controlada; vigila el día</a:t>
+                      </a:r>
+                    </a:p>
+                  </a:txBody>
+                  <a:tcPr>
+                    <a:solidFill>
+                      <a:srgbClr val="FFFFFF"/>
+                    </a:solidFill>
+                  </a:tcPr>
+                </a:tc>
+              </a:tr>
+              <a:tr h="634365">
+                <a:tc>
+                  <a:txBody>
+                    <a:bodyPr/>
+                    <a:lstStyle/>
+                    <a:p>
+                      <a:pPr>
+                        <a:defRPr sz="1000" b="1">
+                          <a:solidFill>
+                            <a:srgbClr val="0D3B66"/>
+                          </a:solidFill>
+                          <a:latin typeface="Calibri"/>
+                        </a:defRPr>
+                      </a:pPr>
+                      <a:r>
+                        <a:t>AEB El Bosque</a:t>
+                      </a:r>
+                    </a:p>
+                  </a:txBody>
+                  <a:tcPr>
+                    <a:solidFill>
+                      <a:srgbClr val="F5F7FA"/>
+                    </a:solidFill>
+                  </a:tcPr>
+                </a:tc>
+                <a:tc>
+                  <a:txBody>
+                    <a:bodyPr/>
+                    <a:lstStyle/>
+                    <a:p>
+                      <a:pPr>
+                        <a:defRPr sz="1000" b="0">
+                          <a:solidFill>
+                            <a:srgbClr val="0D3B66"/>
+                          </a:solidFill>
+                          <a:latin typeface="Calibri"/>
+                        </a:defRPr>
+                      </a:pPr>
+                      <a:r>
+                        <a:t>Nocturno · Matriz 1° piso (11): &gt; 3 m³ 00–06 h</a:t>
+                      </a:r>
+                    </a:p>
+                  </a:txBody>
+                  <a:tcPr>
+                    <a:solidFill>
+                      <a:srgbClr val="F5F7FA"/>
+                    </a:solidFill>
+                  </a:tcPr>
+                </a:tc>
+                <a:tc>
+                  <a:txBody>
+                    <a:bodyPr/>
+                    <a:lstStyle/>
+                    <a:p>
+                      <a:pPr>
+                        <a:defRPr sz="1000" b="0">
+                          <a:solidFill>
+                            <a:srgbClr val="0D3B66"/>
+                          </a:solidFill>
+                          <a:latin typeface="Calibri"/>
+                        </a:defRPr>
+                      </a:pPr>
+                      <a:r>
+                        <a:t>Diario · Anillo Plaza (12): 22 m³/día</a:t>
+                      </a:r>
+                    </a:p>
+                  </a:txBody>
+                  <a:tcPr>
+                    <a:solidFill>
+                      <a:srgbClr val="F5F7FA"/>
+                    </a:solidFill>
+                  </a:tcPr>
+                </a:tc>
+                <a:tc>
+                  <a:txBody>
+                    <a:bodyPr/>
+                    <a:lstStyle/>
+                    <a:p>
+                      <a:pPr>
+                        <a:defRPr sz="1000" b="0">
+                          <a:solidFill>
+                            <a:srgbClr val="0D3B66"/>
+                          </a:solidFill>
+                          <a:latin typeface="Calibri"/>
+                        </a:defRPr>
+                      </a:pPr>
+                      <a:r>
+                        <a:t>10/08 = 6,5 m³; día estable</a:t>
+                      </a:r>
+                    </a:p>
+                  </a:txBody>
+                  <a:tcPr>
+                    <a:solidFill>
+                      <a:srgbClr val="F5F7FA"/>
+                    </a:solidFill>
+                  </a:tcPr>
+                </a:tc>
+              </a:tr>
+              <a:tr h="634365">
+                <a:tc>
+                  <a:txBody>
+                    <a:bodyPr/>
+                    <a:lstStyle/>
+                    <a:p>
+                      <a:pPr>
+                        <a:defRPr sz="1000" b="1">
+                          <a:solidFill>
+                            <a:srgbClr val="0D3B66"/>
+                          </a:solidFill>
+                          <a:latin typeface="Calibri"/>
+                        </a:defRPr>
+                      </a:pPr>
+                      <a:r>
+                        <a:t>CUR Curauma</a:t>
+                      </a:r>
+                    </a:p>
+                  </a:txBody>
+                  <a:tcPr>
+                    <a:solidFill>
+                      <a:srgbClr val="FFFFFF"/>
+                    </a:solidFill>
+                  </a:tcPr>
+                </a:tc>
+                <a:tc>
+                  <a:txBody>
+                    <a:bodyPr/>
+                    <a:lstStyle/>
+                    <a:p>
+                      <a:pPr>
+                        <a:defRPr sz="1000" b="0">
+                          <a:solidFill>
+                            <a:srgbClr val="0D3B66"/>
+                          </a:solidFill>
+                          <a:latin typeface="Calibri"/>
+                        </a:defRPr>
+                      </a:pPr>
+                      <a:r>
+                        <a:t>Diario · Anillo Sur (37): 14 m³/día</a:t>
+                      </a:r>
+                    </a:p>
+                  </a:txBody>
+                  <a:tcPr>
+                    <a:solidFill>
+                      <a:srgbClr val="FFFFFF"/>
+                    </a:solidFill>
+                  </a:tcPr>
+                </a:tc>
+                <a:tc>
+                  <a:txBody>
+                    <a:bodyPr/>
+                    <a:lstStyle/>
+                    <a:p>
+                      <a:pPr>
+                        <a:defRPr sz="1000" b="0">
+                          <a:solidFill>
+                            <a:srgbClr val="0D3B66"/>
+                          </a:solidFill>
+                          <a:latin typeface="Calibri"/>
+                        </a:defRPr>
+                      </a:pPr>
+                      <a:r>
+                        <a:t>Diario · Anillo Norte (38): 13 m³/día</a:t>
+                      </a:r>
+                    </a:p>
+                  </a:txBody>
+                  <a:tcPr>
+                    <a:solidFill>
+                      <a:srgbClr val="FFFFFF"/>
+                    </a:solidFill>
+                  </a:tcPr>
+                </a:tc>
+                <a:tc>
+                  <a:txBody>
+                    <a:bodyPr/>
+                    <a:lstStyle/>
+                    <a:p>
+                      <a:pPr>
+                        <a:defRPr sz="1000" b="0">
+                          <a:solidFill>
+                            <a:srgbClr val="0D3B66"/>
+                          </a:solidFill>
+                          <a:latin typeface="Calibri"/>
+                        </a:defRPr>
+                      </a:pPr>
+                      <a:r>
+                        <a:t>Recinto estable; mayor volumen</a:t>
+                      </a:r>
+                    </a:p>
+                  </a:txBody>
+                  <a:tcPr>
+                    <a:solidFill>
+                      <a:srgbClr val="FFFFFF"/>
+                    </a:solidFill>
+                  </a:tcPr>
+                </a:tc>
+              </a:tr>
+              <a:tr h="634365">
+                <a:tc>
+                  <a:txBody>
+                    <a:bodyPr/>
+                    <a:lstStyle/>
+                    <a:p>
+                      <a:pPr>
+                        <a:defRPr sz="1000" b="1">
+                          <a:solidFill>
+                            <a:srgbClr val="0D3B66"/>
+                          </a:solidFill>
+                          <a:latin typeface="Calibri"/>
+                        </a:defRPr>
+                      </a:pPr>
+                      <a:r>
+                        <a:t>PAK Kennedy</a:t>
+                      </a:r>
+                    </a:p>
+                  </a:txBody>
+                  <a:tcPr>
+                    <a:solidFill>
+                      <a:srgbClr val="F5F7FA"/>
+                    </a:solidFill>
+                  </a:tcPr>
+                </a:tc>
+                <a:tc>
+                  <a:txBody>
+                    <a:bodyPr/>
+                    <a:lstStyle/>
+                    <a:p>
+                      <a:pPr>
+                        <a:defRPr sz="1000" b="0">
+                          <a:solidFill>
+                            <a:srgbClr val="0D3B66"/>
+                          </a:solidFill>
+                          <a:latin typeface="Calibri"/>
+                        </a:defRPr>
+                      </a:pPr>
+                      <a:r>
+                        <a:t>Nocturno · Distrito de Lujo (27): &gt; 15 m³ 00–06 h</a:t>
+                      </a:r>
+                    </a:p>
+                  </a:txBody>
+                  <a:tcPr>
+                    <a:solidFill>
+                      <a:srgbClr val="F5F7FA"/>
+                    </a:solidFill>
+                  </a:tcPr>
+                </a:tc>
+                <a:tc>
+                  <a:txBody>
+                    <a:bodyPr/>
+                    <a:lstStyle/>
+                    <a:p>
+                      <a:pPr>
+                        <a:defRPr sz="1000" b="0">
+                          <a:solidFill>
+                            <a:srgbClr val="0D3B66"/>
+                          </a:solidFill>
+                          <a:latin typeface="Calibri"/>
+                        </a:defRPr>
+                      </a:pPr>
+                      <a:r>
+                        <a:t>Diario · Andén Locales Gastro (21): 180 m³/día</a:t>
+                      </a:r>
+                    </a:p>
+                  </a:txBody>
+                  <a:tcPr>
+                    <a:solidFill>
+                      <a:srgbClr val="F5F7FA"/>
+                    </a:solidFill>
+                  </a:tcPr>
+                </a:tc>
+                <a:tc>
+                  <a:txBody>
+                    <a:bodyPr/>
+                    <a:lstStyle/>
+                    <a:p>
+                      <a:pPr>
+                        <a:defRPr sz="1000" b="0">
+                          <a:solidFill>
+                            <a:srgbClr val="0D3B66"/>
+                          </a:solidFill>
+                          <a:latin typeface="Calibri"/>
+                        </a:defRPr>
+                      </a:pPr>
+                      <a:r>
+                        <a:t>10/08 = 41 m³; mayor impacto</a:t>
+                      </a:r>
+                    </a:p>
+                  </a:txBody>
+                  <a:tcPr>
+                    <a:solidFill>
+                      <a:srgbClr val="F5F7FA"/>
+                    </a:solidFill>
+                  </a:tcPr>
+                </a:tc>
+              </a:tr>
+            </a:tbl>
+          </a:graphicData>
+        </a:graphic>
+      </p:graphicFrame>
+      <p:sp>
+        <p:nvSpPr>
+          <p:cNvPr id="8" name="TextBox 7"/>
+          <p:cNvSpPr txBox="1"/>
+          <p:nvPr/>
+        </p:nvSpPr>
+        <p:spPr>
+          <a:xfrm>
+            <a:off x="256032" y="6291072"/>
+            <a:ext cx="11612880" cy="438912"/>
+          </a:xfrm>
+          <a:prstGeom prst="rect">
+            <a:avLst/>
+          </a:prstGeom>
+          <a:noFill/>
+        </p:spPr>
+        <p:txBody>
+          <a:bodyPr wrap="square">
+            <a:spAutoFit/>
+          </a:bodyPr>
+          <a:lstStyle/>
+          <a:p>
+            <a:pPr algn="l">
+              <a:spcAft>
+                <a:spcPts val="200"/>
+              </a:spcAft>
+            </a:pPr>
+            <a:r>
+              <a:rPr sz="1100" b="0">
+                <a:solidFill>
+                  <a:srgbClr val="5A5A5A"/>
+                </a:solidFill>
+                <a:latin typeface="Calibri"/>
+              </a:rPr>
+              <a:t>No se propone umbral nocturno en SI500, Pizza Hut, Estanque Norte ni Estanque Sur: esa madrugada no se lee como fuga. Falabella (MAM) y Sandía (PAK): sin umbral fijo aún.</a:t>
+            </a:r>
+          </a:p>
+        </p:txBody>
+      </p:sp>
+    </p:spTree>
+  </p:cSld>
+  <p:clrMapOvr>
+    <a:masterClrMapping/>
+  </p:clrMapOvr>
+</p:sld>
+</file>
+
 <file path=ppt/slides/slide2.xml><?xml version="1.0" encoding="utf-8"?>
 <p:sld xmlns:a="http://schemas.openxmlformats.org/drawingml/2006/main" xmlns:p="http://schemas.openxmlformats.org/presentationml/2006/main" xmlns:r="http://schemas.openxmlformats.org/officeDocument/2006/relationships">
   <p:cSld>
@@ -5163,8 +6221,8 @@
         </p:nvSpPr>
         <p:spPr>
           <a:xfrm>
-            <a:off x="320040" y="1051560"/>
-            <a:ext cx="11521440" cy="960120"/>
+            <a:off x="320040" y="987552"/>
+            <a:ext cx="11521440" cy="841248"/>
           </a:xfrm>
           <a:prstGeom prst="roundRect">
             <a:avLst>
@@ -5208,8 +6266,8 @@
         </p:nvSpPr>
         <p:spPr>
           <a:xfrm>
-            <a:off x="457200" y="1124712"/>
-            <a:ext cx="11247120" cy="256032"/>
+            <a:off x="457200" y="1042416"/>
+            <a:ext cx="11247120" cy="219456"/>
           </a:xfrm>
           <a:prstGeom prst="rect">
             <a:avLst/>
@@ -5228,7 +6286,7 @@
               </a:spcAft>
             </a:pPr>
             <a:r>
-              <a:rPr sz="1300" b="1">
+              <a:rPr sz="1200" b="1">
                 <a:solidFill>
                   <a:srgbClr val="0D3B66"/>
                 </a:solidFill>
@@ -5247,8 +6305,8 @@
         </p:nvSpPr>
         <p:spPr>
           <a:xfrm>
-            <a:off x="457200" y="1399031"/>
-            <a:ext cx="11247120" cy="530352"/>
+            <a:off x="457200" y="1280160"/>
+            <a:ext cx="11247120" cy="493776"/>
           </a:xfrm>
           <a:prstGeom prst="rect">
             <a:avLst/>
@@ -5267,7 +6325,7 @@
               </a:spcAft>
             </a:pPr>
             <a:r>
-              <a:rPr sz="1200" b="0">
+              <a:rPr sz="1100" b="0">
                 <a:solidFill>
                   <a:srgbClr val="5A5A5A"/>
                 </a:solidFill>
@@ -5286,8 +6344,8 @@
         </p:nvSpPr>
         <p:spPr>
           <a:xfrm>
-            <a:off x="320040" y="2075688"/>
-            <a:ext cx="11521440" cy="960120"/>
+            <a:off x="320040" y="1883664"/>
+            <a:ext cx="11521440" cy="841248"/>
           </a:xfrm>
           <a:prstGeom prst="roundRect">
             <a:avLst>
@@ -5331,8 +6389,8 @@
         </p:nvSpPr>
         <p:spPr>
           <a:xfrm>
-            <a:off x="457200" y="2148840"/>
-            <a:ext cx="11247120" cy="256032"/>
+            <a:off x="457200" y="1938528"/>
+            <a:ext cx="11247120" cy="219456"/>
           </a:xfrm>
           <a:prstGeom prst="rect">
             <a:avLst/>
@@ -5351,7 +6409,7 @@
               </a:spcAft>
             </a:pPr>
             <a:r>
-              <a:rPr sz="1300" b="1">
+              <a:rPr sz="1200" b="1">
                 <a:solidFill>
                   <a:srgbClr val="0D3B66"/>
                 </a:solidFill>
@@ -5370,8 +6428,8 @@
         </p:nvSpPr>
         <p:spPr>
           <a:xfrm>
-            <a:off x="457200" y="2423160"/>
-            <a:ext cx="11247120" cy="530352"/>
+            <a:off x="457200" y="2176272"/>
+            <a:ext cx="11247120" cy="493776"/>
           </a:xfrm>
           <a:prstGeom prst="rect">
             <a:avLst/>
@@ -5390,7 +6448,7 @@
               </a:spcAft>
             </a:pPr>
             <a:r>
-              <a:rPr sz="1200" b="0">
+              <a:rPr sz="1100" b="0">
                 <a:solidFill>
                   <a:srgbClr val="5A5A5A"/>
                 </a:solidFill>
@@ -5409,8 +6467,8 @@
         </p:nvSpPr>
         <p:spPr>
           <a:xfrm>
-            <a:off x="320040" y="3099816"/>
-            <a:ext cx="11521440" cy="960120"/>
+            <a:off x="320040" y="2779776"/>
+            <a:ext cx="11521440" cy="841248"/>
           </a:xfrm>
           <a:prstGeom prst="roundRect">
             <a:avLst>
@@ -5454,8 +6512,8 @@
         </p:nvSpPr>
         <p:spPr>
           <a:xfrm>
-            <a:off x="457200" y="3172968"/>
-            <a:ext cx="11247120" cy="256032"/>
+            <a:off x="457200" y="2834640"/>
+            <a:ext cx="11247120" cy="219456"/>
           </a:xfrm>
           <a:prstGeom prst="rect">
             <a:avLst/>
@@ -5474,7 +6532,7 @@
               </a:spcAft>
             </a:pPr>
             <a:r>
-              <a:rPr sz="1300" b="1">
+              <a:rPr sz="1200" b="1">
                 <a:solidFill>
                   <a:srgbClr val="0D3B66"/>
                 </a:solidFill>
@@ -5493,8 +6551,8 @@
         </p:nvSpPr>
         <p:spPr>
           <a:xfrm>
-            <a:off x="457200" y="3447288"/>
-            <a:ext cx="11247120" cy="530352"/>
+            <a:off x="457200" y="3072384"/>
+            <a:ext cx="11247120" cy="493776"/>
           </a:xfrm>
           <a:prstGeom prst="rect">
             <a:avLst/>
@@ -5513,7 +6571,7 @@
               </a:spcAft>
             </a:pPr>
             <a:r>
-              <a:rPr sz="1200" b="0">
+              <a:rPr sz="1100" b="0">
                 <a:solidFill>
                   <a:srgbClr val="5A5A5A"/>
                 </a:solidFill>
@@ -5532,8 +6590,8 @@
         </p:nvSpPr>
         <p:spPr>
           <a:xfrm>
-            <a:off x="320040" y="4123944"/>
-            <a:ext cx="11521440" cy="960120"/>
+            <a:off x="320040" y="3675887"/>
+            <a:ext cx="11521440" cy="841248"/>
           </a:xfrm>
           <a:prstGeom prst="roundRect">
             <a:avLst>
@@ -5577,8 +6635,8 @@
         </p:nvSpPr>
         <p:spPr>
           <a:xfrm>
-            <a:off x="457200" y="4197096"/>
-            <a:ext cx="11247120" cy="256032"/>
+            <a:off x="457200" y="3730751"/>
+            <a:ext cx="11247120" cy="219456"/>
           </a:xfrm>
           <a:prstGeom prst="rect">
             <a:avLst/>
@@ -5597,7 +6655,7 @@
               </a:spcAft>
             </a:pPr>
             <a:r>
-              <a:rPr sz="1300" b="1">
+              <a:rPr sz="1200" b="1">
                 <a:solidFill>
                   <a:srgbClr val="0D3B66"/>
                 </a:solidFill>
@@ -5616,8 +6674,8 @@
         </p:nvSpPr>
         <p:spPr>
           <a:xfrm>
-            <a:off x="457200" y="4471416"/>
-            <a:ext cx="11247120" cy="530352"/>
+            <a:off x="457200" y="3968496"/>
+            <a:ext cx="11247120" cy="493776"/>
           </a:xfrm>
           <a:prstGeom prst="rect">
             <a:avLst/>
@@ -5636,7 +6694,7 @@
               </a:spcAft>
             </a:pPr>
             <a:r>
-              <a:rPr sz="1200" b="0">
+              <a:rPr sz="1100" b="0">
                 <a:solidFill>
                   <a:srgbClr val="5A5A5A"/>
                 </a:solidFill>
@@ -5655,8 +6713,8 @@
         </p:nvSpPr>
         <p:spPr>
           <a:xfrm>
-            <a:off x="320040" y="5148072"/>
-            <a:ext cx="11521440" cy="960120"/>
+            <a:off x="320040" y="4572000"/>
+            <a:ext cx="11521440" cy="841248"/>
           </a:xfrm>
           <a:prstGeom prst="roundRect">
             <a:avLst>
@@ -5700,8 +6758,8 @@
         </p:nvSpPr>
         <p:spPr>
           <a:xfrm>
-            <a:off x="457200" y="5221224"/>
-            <a:ext cx="11247120" cy="256032"/>
+            <a:off x="457200" y="4626864"/>
+            <a:ext cx="11247120" cy="219456"/>
           </a:xfrm>
           <a:prstGeom prst="rect">
             <a:avLst/>
@@ -5720,7 +6778,7 @@
               </a:spcAft>
             </a:pPr>
             <a:r>
-              <a:rPr sz="1300" b="1">
+              <a:rPr sz="1200" b="1">
                 <a:solidFill>
                   <a:srgbClr val="0D3B66"/>
                 </a:solidFill>
@@ -5739,8 +6797,8 @@
         </p:nvSpPr>
         <p:spPr>
           <a:xfrm>
-            <a:off x="457200" y="5495544"/>
-            <a:ext cx="11247120" cy="530352"/>
+            <a:off x="457200" y="4864608"/>
+            <a:ext cx="11247120" cy="493776"/>
           </a:xfrm>
           <a:prstGeom prst="rect">
             <a:avLst/>
@@ -5759,13 +6817,136 @@
               </a:spcAft>
             </a:pPr>
             <a:r>
-              <a:rPr sz="1200" b="0">
+              <a:rPr sz="1100" b="0">
                 <a:solidFill>
                   <a:srgbClr val="5A5A5A"/>
                 </a:solidFill>
                 <a:latin typeface="Calibri"/>
               </a:rPr>
               <a:t>Si el punto tiene control on/off (o corte de mantención), el caudal de madrugada no se interpreta como fuga. San Ignacio 500 desde 16/07 · Pizza Hut desde 01/07 · Estanque Norte desde 05/08 · Estanque Sur: corte de mantención nocturna.</a:t>
+            </a:r>
+          </a:p>
+        </p:txBody>
+      </p:sp>
+      <p:sp>
+        <p:nvSpPr>
+          <p:cNvPr id="22" name="Rounded Rectangle 21"/>
+          <p:cNvSpPr/>
+          <p:nvPr/>
+        </p:nvSpPr>
+        <p:spPr>
+          <a:xfrm>
+            <a:off x="320040" y="5468112"/>
+            <a:ext cx="11521440" cy="841248"/>
+          </a:xfrm>
+          <a:prstGeom prst="roundRect">
+            <a:avLst>
+              <a:gd name="adj" fmla="val 8000"/>
+            </a:avLst>
+          </a:prstGeom>
+          <a:solidFill>
+            <a:srgbClr val="F5F7FA"/>
+          </a:solidFill>
+          <a:ln>
+            <a:noFill/>
+          </a:ln>
+        </p:spPr>
+        <p:style>
+          <a:lnRef idx="1">
+            <a:schemeClr val="accent1"/>
+          </a:lnRef>
+          <a:fillRef idx="3">
+            <a:schemeClr val="accent1"/>
+          </a:fillRef>
+          <a:effectRef idx="2">
+            <a:schemeClr val="accent1"/>
+          </a:effectRef>
+          <a:fontRef idx="minor">
+            <a:schemeClr val="lt1"/>
+          </a:fontRef>
+        </p:style>
+        <p:txBody>
+          <a:bodyPr rtlCol="0" anchor="ctr"/>
+          <a:lstStyle/>
+          <a:p>
+            <a:pPr algn="ctr"/>
+          </a:p>
+        </p:txBody>
+      </p:sp>
+      <p:sp>
+        <p:nvSpPr>
+          <p:cNvPr id="23" name="TextBox 22"/>
+          <p:cNvSpPr txBox="1"/>
+          <p:nvPr/>
+        </p:nvSpPr>
+        <p:spPr>
+          <a:xfrm>
+            <a:off x="457200" y="5522976"/>
+            <a:ext cx="11247120" cy="219456"/>
+          </a:xfrm>
+          <a:prstGeom prst="rect">
+            <a:avLst/>
+          </a:prstGeom>
+          <a:noFill/>
+        </p:spPr>
+        <p:txBody>
+          <a:bodyPr wrap="square">
+            <a:spAutoFit/>
+          </a:bodyPr>
+          <a:lstStyle/>
+          <a:p>
+            <a:pPr algn="l">
+              <a:spcAft>
+                <a:spcPts val="200"/>
+              </a:spcAft>
+            </a:pPr>
+            <a:r>
+              <a:rPr sz="1200" b="1">
+                <a:solidFill>
+                  <a:srgbClr val="0D3B66"/>
+                </a:solidFill>
+                <a:latin typeface="Calibri"/>
+              </a:rPr>
+              <a:t>6. Alertas de umbral (reunión)</a:t>
+            </a:r>
+          </a:p>
+        </p:txBody>
+      </p:sp>
+      <p:sp>
+        <p:nvSpPr>
+          <p:cNvPr id="24" name="TextBox 23"/>
+          <p:cNvSpPr txBox="1"/>
+          <p:nvPr/>
+        </p:nvSpPr>
+        <p:spPr>
+          <a:xfrm>
+            <a:off x="457200" y="5760720"/>
+            <a:ext cx="11247120" cy="493776"/>
+          </a:xfrm>
+          <a:prstGeom prst="rect">
+            <a:avLst/>
+          </a:prstGeom>
+          <a:noFill/>
+        </p:spPr>
+        <p:txBody>
+          <a:bodyPr wrap="square">
+            <a:spAutoFit/>
+          </a:bodyPr>
+          <a:lstStyle/>
+          <a:p>
+            <a:pPr algn="l">
+              <a:spcAft>
+                <a:spcPts val="200"/>
+              </a:spcAft>
+            </a:pPr>
+            <a:r>
+              <a:rPr sz="1100" b="0">
+                <a:solidFill>
+                  <a:srgbClr val="5A5A5A"/>
+                </a:solidFill>
+                <a:latin typeface="Calibri"/>
+              </a:rPr>
+              <a:t>1 o 2 cortes por mall para cargar en WES. Diario = promedio operativo × 1,25. Nocturno = m³ en 00:00–06:00. No se propone umbral de madrugada en puntos que ya tienen control (esa noche no se lee como fuga).</a:t>
             </a:r>
           </a:p>
         </p:txBody>
@@ -5985,7 +7166,7 @@
         <p:spPr>
           <a:xfrm>
             <a:off x="228600" y="1024128"/>
-            <a:ext cx="3977639" cy="2331720"/>
+            <a:ext cx="3977639" cy="2212848"/>
           </a:xfrm>
           <a:prstGeom prst="roundRect">
             <a:avLst>
@@ -6029,7 +7210,7 @@
         </p:nvSpPr>
         <p:spPr>
           <a:xfrm>
-            <a:off x="347472" y="1078992"/>
+            <a:off x="347472" y="1060704"/>
             <a:ext cx="3749039" cy="256032"/>
           </a:xfrm>
           <a:prstGeom prst="rect">
@@ -6068,8 +7249,8 @@
         </p:nvSpPr>
         <p:spPr>
           <a:xfrm>
-            <a:off x="347472" y="1353312"/>
-            <a:ext cx="3749039" cy="1920240"/>
+            <a:off x="347472" y="1316736"/>
+            <a:ext cx="3749039" cy="1847088"/>
           </a:xfrm>
           <a:prstGeom prst="rect">
             <a:avLst/>
@@ -6172,7 +7353,7 @@
         <p:spPr>
           <a:xfrm>
             <a:off x="4297680" y="1024128"/>
-            <a:ext cx="7635240" cy="2331720"/>
+            <a:ext cx="7635240" cy="2212848"/>
           </a:xfrm>
           <a:prstGeom prst="roundRect">
             <a:avLst>
@@ -6216,7 +7397,7 @@
         </p:nvSpPr>
         <p:spPr>
           <a:xfrm>
-            <a:off x="4434840" y="1078992"/>
+            <a:off x="4434840" y="1060704"/>
             <a:ext cx="3657600" cy="256032"/>
           </a:xfrm>
           <a:prstGeom prst="rect">
@@ -6255,8 +7436,8 @@
         </p:nvSpPr>
         <p:spPr>
           <a:xfrm>
-            <a:off x="4434840" y="1353312"/>
-            <a:ext cx="3611880" cy="1920240"/>
+            <a:off x="4434840" y="1316736"/>
+            <a:ext cx="3611880" cy="1847088"/>
           </a:xfrm>
           <a:prstGeom prst="rect">
             <a:avLst/>
@@ -6398,7 +7579,7 @@
         </p:blipFill>
         <p:spPr>
           <a:xfrm>
-            <a:off x="8138160" y="1325880"/>
+            <a:off x="8138160" y="1280160"/>
             <a:ext cx="3611880" cy="1488617"/>
           </a:xfrm>
           <a:prstGeom prst="rect">
@@ -6414,8 +7595,8 @@
         </p:nvSpPr>
         <p:spPr>
           <a:xfrm>
-            <a:off x="228600" y="3456432"/>
-            <a:ext cx="5852160" cy="1874519"/>
+            <a:off x="228600" y="3310128"/>
+            <a:ext cx="5852160" cy="1444752"/>
           </a:xfrm>
           <a:prstGeom prst="roundRect">
             <a:avLst>
@@ -6459,7 +7640,7 @@
         </p:nvSpPr>
         <p:spPr>
           <a:xfrm>
-            <a:off x="347472" y="3511296"/>
+            <a:off x="347472" y="3346704"/>
             <a:ext cx="5577840" cy="256032"/>
           </a:xfrm>
           <a:prstGeom prst="rect">
@@ -6498,8 +7679,8 @@
         </p:nvSpPr>
         <p:spPr>
           <a:xfrm>
-            <a:off x="347472" y="3785615"/>
-            <a:ext cx="5596128" cy="1481328"/>
+            <a:off x="347472" y="3602736"/>
+            <a:ext cx="5596128" cy="1097280"/>
           </a:xfrm>
           <a:prstGeom prst="rect">
             <a:avLst/>
@@ -6518,7 +7699,7 @@
               </a:spcAft>
             </a:pPr>
             <a:r>
-              <a:rPr sz="1000" b="0">
+              <a:rPr sz="900" b="0">
                 <a:solidFill>
                   <a:srgbClr val="0D3B66"/>
                 </a:solidFill>
@@ -6534,7 +7715,7 @@
               </a:spcAft>
             </a:pPr>
             <a:r>
-              <a:rPr sz="1000" b="0">
+              <a:rPr sz="900" b="0">
                 <a:solidFill>
                   <a:srgbClr val="0D3B66"/>
                 </a:solidFill>
@@ -6550,7 +7731,7 @@
               </a:spcAft>
             </a:pPr>
             <a:r>
-              <a:rPr sz="1000" b="0">
+              <a:rPr sz="900" b="0">
                 <a:solidFill>
                   <a:srgbClr val="0D3B66"/>
                 </a:solidFill>
@@ -6566,7 +7747,7 @@
               </a:spcAft>
             </a:pPr>
             <a:r>
-              <a:rPr sz="1000" b="0">
+              <a:rPr sz="900" b="0">
                 <a:solidFill>
                   <a:srgbClr val="0D3B66"/>
                 </a:solidFill>
@@ -6585,8 +7766,8 @@
         </p:nvSpPr>
         <p:spPr>
           <a:xfrm>
-            <a:off x="6217920" y="3456432"/>
-            <a:ext cx="5715000" cy="1874519"/>
+            <a:off x="6217920" y="3310128"/>
+            <a:ext cx="5715000" cy="1444752"/>
           </a:xfrm>
           <a:prstGeom prst="roundRect">
             <a:avLst>
@@ -6630,7 +7811,7 @@
         </p:nvSpPr>
         <p:spPr>
           <a:xfrm>
-            <a:off x="6336792" y="3511296"/>
+            <a:off x="6336792" y="3346704"/>
             <a:ext cx="5486400" cy="256032"/>
           </a:xfrm>
           <a:prstGeom prst="rect">
@@ -6669,8 +7850,8 @@
         </p:nvSpPr>
         <p:spPr>
           <a:xfrm>
-            <a:off x="6336792" y="3785615"/>
-            <a:ext cx="5468112" cy="1481328"/>
+            <a:off x="6336792" y="3602736"/>
+            <a:ext cx="5468112" cy="1097280"/>
           </a:xfrm>
           <a:prstGeom prst="rect">
             <a:avLst/>
@@ -6689,7 +7870,7 @@
               </a:spcAft>
             </a:pPr>
             <a:r>
-              <a:rPr sz="1000" b="0">
+              <a:rPr sz="900" b="0">
                 <a:solidFill>
                   <a:srgbClr val="0D3B66"/>
                 </a:solidFill>
@@ -6705,7 +7886,7 @@
               </a:spcAft>
             </a:pPr>
             <a:r>
-              <a:rPr sz="1000" b="0">
+              <a:rPr sz="900" b="0">
                 <a:solidFill>
                   <a:srgbClr val="0D3B66"/>
                 </a:solidFill>
@@ -6721,29 +7902,13 @@
               </a:spcAft>
             </a:pPr>
             <a:r>
-              <a:rPr sz="1000" b="0">
+              <a:rPr sz="900" b="0">
                 <a:solidFill>
                   <a:srgbClr val="0D3B66"/>
                 </a:solidFill>
                 <a:latin typeface="Calibri"/>
               </a:rPr>
               <a:t>• Revisar alza diurna de Estanque Norte en agosto (locales mall).</a:t>
-            </a:r>
-          </a:p>
-          <a:p>
-            <a:pPr algn="l">
-              <a:spcAft>
-                <a:spcPts val="200"/>
-              </a:spcAft>
-            </a:pPr>
-            <a:r>
-              <a:rPr sz="1000" b="0">
-                <a:solidFill>
-                  <a:srgbClr val="0D3B66"/>
-                </a:solidFill>
-                <a:latin typeface="Calibri"/>
-              </a:rPr>
-              <a:t>• Incorporar Abastecimiento Sur Terminal (000025-02) al tablero del recinto si corresponde a la cuenta del mall.</a:t>
             </a:r>
           </a:p>
         </p:txBody>
@@ -6756,8 +7921,149 @@
         </p:nvSpPr>
         <p:spPr>
           <a:xfrm>
-            <a:off x="228600" y="5440680"/>
-            <a:ext cx="11704320" cy="1261872"/>
+            <a:off x="228600" y="4828032"/>
+            <a:ext cx="11704320" cy="1115568"/>
+          </a:xfrm>
+          <a:prstGeom prst="roundRect">
+            <a:avLst>
+              <a:gd name="adj" fmla="val 8000"/>
+            </a:avLst>
+          </a:prstGeom>
+          <a:solidFill>
+            <a:srgbClr val="E8F4F8"/>
+          </a:solidFill>
+          <a:ln w="6350">
+            <a:solidFill>
+              <a:srgbClr val="1F77B4"/>
+            </a:solidFill>
+          </a:ln>
+        </p:spPr>
+        <p:style>
+          <a:lnRef idx="1">
+            <a:schemeClr val="accent1"/>
+          </a:lnRef>
+          <a:fillRef idx="3">
+            <a:schemeClr val="accent1"/>
+          </a:fillRef>
+          <a:effectRef idx="2">
+            <a:schemeClr val="accent1"/>
+          </a:effectRef>
+          <a:fontRef idx="minor">
+            <a:schemeClr val="lt1"/>
+          </a:fontRef>
+        </p:style>
+        <p:txBody>
+          <a:bodyPr rtlCol="0" anchor="ctr"/>
+          <a:lstStyle/>
+          <a:p>
+            <a:pPr algn="ctr"/>
+          </a:p>
+        </p:txBody>
+      </p:sp>
+      <p:sp>
+        <p:nvSpPr>
+          <p:cNvPr id="21" name="TextBox 20"/>
+          <p:cNvSpPr txBox="1"/>
+          <p:nvPr/>
+        </p:nvSpPr>
+        <p:spPr>
+          <a:xfrm>
+            <a:off x="347472" y="4864608"/>
+            <a:ext cx="11430000" cy="256032"/>
+          </a:xfrm>
+          <a:prstGeom prst="rect">
+            <a:avLst/>
+          </a:prstGeom>
+          <a:noFill/>
+        </p:spPr>
+        <p:txBody>
+          <a:bodyPr wrap="square">
+            <a:spAutoFit/>
+          </a:bodyPr>
+          <a:lstStyle/>
+          <a:p>
+            <a:pPr algn="l">
+              <a:spcAft>
+                <a:spcPts val="200"/>
+              </a:spcAft>
+            </a:pPr>
+            <a:r>
+              <a:rPr sz="1100" b="1">
+                <a:solidFill>
+                  <a:srgbClr val="1F77B4"/>
+                </a:solidFill>
+                <a:latin typeface="Calibri"/>
+              </a:rPr>
+              <a:t>6. ALERTAS DE UMBRAL — PROPONER EN LA REUNIÓN</a:t>
+            </a:r>
+          </a:p>
+        </p:txBody>
+      </p:sp>
+      <p:sp>
+        <p:nvSpPr>
+          <p:cNvPr id="22" name="TextBox 21"/>
+          <p:cNvSpPr txBox="1"/>
+          <p:nvPr/>
+        </p:nvSpPr>
+        <p:spPr>
+          <a:xfrm>
+            <a:off x="347472" y="5120640"/>
+            <a:ext cx="11430000" cy="768096"/>
+          </a:xfrm>
+          <a:prstGeom prst="rect">
+            <a:avLst/>
+          </a:prstGeom>
+          <a:noFill/>
+        </p:spPr>
+        <p:txBody>
+          <a:bodyPr wrap="square">
+            <a:spAutoFit/>
+          </a:bodyPr>
+          <a:lstStyle/>
+          <a:p>
+            <a:pPr algn="l">
+              <a:spcAft>
+                <a:spcPts val="200"/>
+              </a:spcAft>
+            </a:pPr>
+            <a:r>
+              <a:rPr sz="1000" b="0">
+                <a:solidFill>
+                  <a:srgbClr val="0D3B66"/>
+                </a:solidFill>
+                <a:latin typeface="Calibri"/>
+              </a:rPr>
+              <a:t>• Estanque Norte (000025-01): umbral diario 40 m³/día. Base jun–jul ~25; agosto ~52 y el 16/08 = 93. Marca el alza diurna de locales (la noche ya tiene control).</a:t>
+            </a:r>
+          </a:p>
+          <a:p>
+            <a:pPr algn="l">
+              <a:spcAft>
+                <a:spcPts val="200"/>
+              </a:spcAft>
+            </a:pPr>
+            <a:r>
+              <a:rPr sz="1000" b="0">
+                <a:solidFill>
+                  <a:srgbClr val="0D3B66"/>
+                </a:solidFill>
+                <a:latin typeface="Calibri"/>
+              </a:rPr>
+              <a:t>• Pizza Hut (000025-07): umbral diario 25 m³/día. Agosto ~14 m³/día; julio se disparó (hasta 195). Avisa si vuelve el alza diurna. Sin umbral de madrugada: control 00:00–06:00 activo.</a:t>
+            </a:r>
+          </a:p>
+        </p:txBody>
+      </p:sp>
+      <p:sp>
+        <p:nvSpPr>
+          <p:cNvPr id="23" name="Rounded Rectangle 22"/>
+          <p:cNvSpPr/>
+          <p:nvPr/>
+        </p:nvSpPr>
+        <p:spPr>
+          <a:xfrm>
+            <a:off x="228600" y="6016752"/>
+            <a:ext cx="11704320" cy="731520"/>
           </a:xfrm>
           <a:prstGeom prst="roundRect">
             <a:avLst>
@@ -6797,13 +8103,13 @@
       </p:sp>
       <p:sp>
         <p:nvSpPr>
-          <p:cNvPr id="21" name="TextBox 20"/>
+          <p:cNvPr id="24" name="TextBox 23"/>
           <p:cNvSpPr txBox="1"/>
           <p:nvPr/>
         </p:nvSpPr>
         <p:spPr>
           <a:xfrm>
-            <a:off x="347472" y="5486400"/>
+            <a:off x="347472" y="6035040"/>
             <a:ext cx="11430000" cy="256032"/>
           </a:xfrm>
           <a:prstGeom prst="rect">
@@ -6836,14 +8142,14 @@
       </p:sp>
       <p:sp>
         <p:nvSpPr>
-          <p:cNvPr id="22" name="TextBox 21"/>
+          <p:cNvPr id="25" name="TextBox 24"/>
           <p:cNvSpPr txBox="1"/>
           <p:nvPr/>
         </p:nvSpPr>
         <p:spPr>
           <a:xfrm>
-            <a:off x="347472" y="5742432"/>
-            <a:ext cx="11430000" cy="896112"/>
+            <a:off x="347472" y="6272784"/>
+            <a:ext cx="11430000" cy="438912"/>
           </a:xfrm>
           <a:prstGeom prst="rect">
             <a:avLst/>
@@ -6862,7 +8168,7 @@
               </a:spcAft>
             </a:pPr>
             <a:r>
-              <a:rPr sz="1100" b="0">
+              <a:rPr sz="1000" b="0">
                 <a:solidFill>
                   <a:srgbClr val="0D3B66"/>
                 </a:solidFill>
@@ -6878,7 +8184,7 @@
               </a:spcAft>
             </a:pPr>
             <a:r>
-              <a:rPr sz="1100" b="0">
+              <a:rPr sz="1000" b="0">
                 <a:solidFill>
                   <a:srgbClr val="0D3B66"/>
                 </a:solidFill>
@@ -6894,29 +8200,13 @@
               </a:spcAft>
             </a:pPr>
             <a:r>
-              <a:rPr sz="1100" b="0">
+              <a:rPr sz="1000" b="0">
                 <a:solidFill>
                   <a:srgbClr val="0D3B66"/>
                 </a:solidFill>
                 <a:latin typeface="Calibri"/>
               </a:rPr>
               <a:t>• Estanque Norte (000025-01): control desde 05/08. La madrugada NO se lee como fuga (el alza de agosto es diurna).</a:t>
-            </a:r>
-          </a:p>
-          <a:p>
-            <a:pPr algn="l">
-              <a:spcAft>
-                <a:spcPts val="200"/>
-              </a:spcAft>
-            </a:pPr>
-            <a:r>
-              <a:rPr sz="1100" b="0">
-                <a:solidFill>
-                  <a:srgbClr val="0D3B66"/>
-                </a:solidFill>
-                <a:latin typeface="Calibri"/>
-              </a:rPr>
-              <a:t>• Baños Públicos: control instalado sin uso; noches ya ~0. Tampoco se interpreta como fuga.</a:t>
             </a:r>
           </a:p>
         </p:txBody>
@@ -7136,7 +8426,7 @@
         <p:spPr>
           <a:xfrm>
             <a:off x="228600" y="1024128"/>
-            <a:ext cx="3977639" cy="2331720"/>
+            <a:ext cx="3977639" cy="2212848"/>
           </a:xfrm>
           <a:prstGeom prst="roundRect">
             <a:avLst>
@@ -7180,7 +8470,7 @@
         </p:nvSpPr>
         <p:spPr>
           <a:xfrm>
-            <a:off x="347472" y="1078992"/>
+            <a:off x="347472" y="1060704"/>
             <a:ext cx="3749039" cy="256032"/>
           </a:xfrm>
           <a:prstGeom prst="rect">
@@ -7219,8 +8509,8 @@
         </p:nvSpPr>
         <p:spPr>
           <a:xfrm>
-            <a:off x="347472" y="1353312"/>
-            <a:ext cx="3749039" cy="1920240"/>
+            <a:off x="347472" y="1316736"/>
+            <a:ext cx="3749039" cy="1847088"/>
           </a:xfrm>
           <a:prstGeom prst="rect">
             <a:avLst/>
@@ -7323,7 +8613,7 @@
         <p:spPr>
           <a:xfrm>
             <a:off x="4297680" y="1024128"/>
-            <a:ext cx="7635240" cy="2331720"/>
+            <a:ext cx="7635240" cy="2212848"/>
           </a:xfrm>
           <a:prstGeom prst="roundRect">
             <a:avLst>
@@ -7367,7 +8657,7 @@
         </p:nvSpPr>
         <p:spPr>
           <a:xfrm>
-            <a:off x="4434840" y="1078992"/>
+            <a:off x="4434840" y="1060704"/>
             <a:ext cx="3657600" cy="256032"/>
           </a:xfrm>
           <a:prstGeom prst="rect">
@@ -7406,8 +8696,8 @@
         </p:nvSpPr>
         <p:spPr>
           <a:xfrm>
-            <a:off x="4434840" y="1353312"/>
-            <a:ext cx="3611880" cy="1920240"/>
+            <a:off x="4434840" y="1316736"/>
+            <a:ext cx="3611880" cy="1847088"/>
           </a:xfrm>
           <a:prstGeom prst="rect">
             <a:avLst/>
@@ -7533,7 +8823,7 @@
         </p:blipFill>
         <p:spPr>
           <a:xfrm>
-            <a:off x="8138160" y="1325880"/>
+            <a:off x="8138160" y="1280160"/>
             <a:ext cx="3611880" cy="1488617"/>
           </a:xfrm>
           <a:prstGeom prst="rect">
@@ -7549,8 +8839,8 @@
         </p:nvSpPr>
         <p:spPr>
           <a:xfrm>
-            <a:off x="228600" y="3456432"/>
-            <a:ext cx="5852160" cy="1874519"/>
+            <a:off x="228600" y="3310128"/>
+            <a:ext cx="5852160" cy="1444752"/>
           </a:xfrm>
           <a:prstGeom prst="roundRect">
             <a:avLst>
@@ -7594,7 +8884,7 @@
         </p:nvSpPr>
         <p:spPr>
           <a:xfrm>
-            <a:off x="347472" y="3511296"/>
+            <a:off x="347472" y="3346704"/>
             <a:ext cx="5577840" cy="256032"/>
           </a:xfrm>
           <a:prstGeom prst="rect">
@@ -7633,8 +8923,8 @@
         </p:nvSpPr>
         <p:spPr>
           <a:xfrm>
-            <a:off x="347472" y="3785615"/>
-            <a:ext cx="5596128" cy="1481328"/>
+            <a:off x="347472" y="3602736"/>
+            <a:ext cx="5596128" cy="1097280"/>
           </a:xfrm>
           <a:prstGeom prst="rect">
             <a:avLst/>
@@ -7653,7 +8943,7 @@
               </a:spcAft>
             </a:pPr>
             <a:r>
-              <a:rPr sz="1000" b="0">
+              <a:rPr sz="900" b="0">
                 <a:solidFill>
                   <a:srgbClr val="0D3B66"/>
                 </a:solidFill>
@@ -7669,7 +8959,7 @@
               </a:spcAft>
             </a:pPr>
             <a:r>
-              <a:rPr sz="1000" b="0">
+              <a:rPr sz="900" b="0">
                 <a:solidFill>
                   <a:srgbClr val="0D3B66"/>
                 </a:solidFill>
@@ -7685,7 +8975,7 @@
               </a:spcAft>
             </a:pPr>
             <a:r>
-              <a:rPr sz="1000" b="0">
+              <a:rPr sz="900" b="0">
                 <a:solidFill>
                   <a:srgbClr val="0D3B66"/>
                 </a:solidFill>
@@ -7701,29 +8991,13 @@
               </a:spcAft>
             </a:pPr>
             <a:r>
-              <a:rPr sz="1000" b="0">
+              <a:rPr sz="900" b="0">
                 <a:solidFill>
                   <a:srgbClr val="0D3B66"/>
                 </a:solidFill>
                 <a:latin typeface="Calibri"/>
               </a:rPr>
               <a:t>• Pasillo Técnico Boulevard y salida ARROW: consumo residual (71,7 y 1,2 m³ en el período).</a:t>
-            </a:r>
-          </a:p>
-          <a:p>
-            <a:pPr algn="l">
-              <a:spcAft>
-                <a:spcPts val="200"/>
-              </a:spcAft>
-            </a:pPr>
-            <a:r>
-              <a:rPr sz="1000" b="0">
-                <a:solidFill>
-                  <a:srgbClr val="0D3B66"/>
-                </a:solidFill>
-                <a:latin typeface="Calibri"/>
-              </a:rPr>
-              <a:t>• Impulsión Falabella (000025-09) ACTIVA desde el 11/08/2026. Jun–jul = 0 m³ (equipo fuera). Serie 11/08–16/08: 24,6 / 55,3 / 66,1 / 24,1 / 120,5 / 112 m³ (acum. 402,6 m³). Noche 12/08 6,8 m³ y 13/08 11,2 m³ (0–6 h). Sin control nocturno; baseline 2–3 semanas.</a:t>
             </a:r>
           </a:p>
         </p:txBody>
@@ -7736,8 +9010,8 @@
         </p:nvSpPr>
         <p:spPr>
           <a:xfrm>
-            <a:off x="6217920" y="3456432"/>
-            <a:ext cx="5715000" cy="1874519"/>
+            <a:off x="6217920" y="3310128"/>
+            <a:ext cx="5715000" cy="1444752"/>
           </a:xfrm>
           <a:prstGeom prst="roundRect">
             <a:avLst>
@@ -7781,7 +9055,7 @@
         </p:nvSpPr>
         <p:spPr>
           <a:xfrm>
-            <a:off x="6336792" y="3511296"/>
+            <a:off x="6336792" y="3346704"/>
             <a:ext cx="5486400" cy="256032"/>
           </a:xfrm>
           <a:prstGeom prst="rect">
@@ -7820,8 +9094,8 @@
         </p:nvSpPr>
         <p:spPr>
           <a:xfrm>
-            <a:off x="6336792" y="3785615"/>
-            <a:ext cx="5468112" cy="1481328"/>
+            <a:off x="6336792" y="3602736"/>
+            <a:ext cx="5468112" cy="1097280"/>
           </a:xfrm>
           <a:prstGeom prst="rect">
             <a:avLst/>
@@ -7840,7 +9114,7 @@
               </a:spcAft>
             </a:pPr>
             <a:r>
-              <a:rPr sz="1000" b="0">
+              <a:rPr sz="900" b="0">
                 <a:solidFill>
                   <a:srgbClr val="0D3B66"/>
                 </a:solidFill>
@@ -7856,7 +9130,7 @@
               </a:spcAft>
             </a:pPr>
             <a:r>
-              <a:rPr sz="1000" b="0">
+              <a:rPr sz="900" b="0">
                 <a:solidFill>
                   <a:srgbClr val="0D3B66"/>
                 </a:solidFill>
@@ -7872,29 +9146,13 @@
               </a:spcAft>
             </a:pPr>
             <a:r>
-              <a:rPr sz="1000" b="0">
+              <a:rPr sz="900" b="0">
                 <a:solidFill>
                   <a:srgbClr val="0D3B66"/>
                 </a:solidFill>
                 <a:latin typeface="Calibri"/>
               </a:rPr>
               <a:t>• Mantener seguimiento de Placa Bancaria: el alza del 18/06 se revirtió en agosto; no reabrir como fuga nocturna.</a:t>
-            </a:r>
-          </a:p>
-          <a:p>
-            <a:pPr algn="l">
-              <a:spcAft>
-                <a:spcPts val="200"/>
-              </a:spcAft>
-            </a:pPr>
-            <a:r>
-              <a:rPr sz="1000" b="0">
-                <a:solidFill>
-                  <a:srgbClr val="0D3B66"/>
-                </a:solidFill>
-                <a:latin typeface="Calibri"/>
-              </a:rPr>
-              <a:t>• Pasillo y ARROW: dejar como referencia de red (no priorizar).</a:t>
             </a:r>
           </a:p>
         </p:txBody>
@@ -7907,8 +9165,149 @@
         </p:nvSpPr>
         <p:spPr>
           <a:xfrm>
-            <a:off x="228600" y="5440680"/>
-            <a:ext cx="11704320" cy="1261872"/>
+            <a:off x="228600" y="4828032"/>
+            <a:ext cx="11704320" cy="1115568"/>
+          </a:xfrm>
+          <a:prstGeom prst="roundRect">
+            <a:avLst>
+              <a:gd name="adj" fmla="val 8000"/>
+            </a:avLst>
+          </a:prstGeom>
+          <a:solidFill>
+            <a:srgbClr val="E8F4F8"/>
+          </a:solidFill>
+          <a:ln w="6350">
+            <a:solidFill>
+              <a:srgbClr val="1F77B4"/>
+            </a:solidFill>
+          </a:ln>
+        </p:spPr>
+        <p:style>
+          <a:lnRef idx="1">
+            <a:schemeClr val="accent1"/>
+          </a:lnRef>
+          <a:fillRef idx="3">
+            <a:schemeClr val="accent1"/>
+          </a:fillRef>
+          <a:effectRef idx="2">
+            <a:schemeClr val="accent1"/>
+          </a:effectRef>
+          <a:fontRef idx="minor">
+            <a:schemeClr val="lt1"/>
+          </a:fontRef>
+        </p:style>
+        <p:txBody>
+          <a:bodyPr rtlCol="0" anchor="ctr"/>
+          <a:lstStyle/>
+          <a:p>
+            <a:pPr algn="ctr"/>
+          </a:p>
+        </p:txBody>
+      </p:sp>
+      <p:sp>
+        <p:nvSpPr>
+          <p:cNvPr id="21" name="TextBox 20"/>
+          <p:cNvSpPr txBox="1"/>
+          <p:nvPr/>
+        </p:nvSpPr>
+        <p:spPr>
+          <a:xfrm>
+            <a:off x="347472" y="4864608"/>
+            <a:ext cx="11430000" cy="256032"/>
+          </a:xfrm>
+          <a:prstGeom prst="rect">
+            <a:avLst/>
+          </a:prstGeom>
+          <a:noFill/>
+        </p:spPr>
+        <p:txBody>
+          <a:bodyPr wrap="square">
+            <a:spAutoFit/>
+          </a:bodyPr>
+          <a:lstStyle/>
+          <a:p>
+            <a:pPr algn="l">
+              <a:spcAft>
+                <a:spcPts val="200"/>
+              </a:spcAft>
+            </a:pPr>
+            <a:r>
+              <a:rPr sz="1100" b="1">
+                <a:solidFill>
+                  <a:srgbClr val="1F77B4"/>
+                </a:solidFill>
+                <a:latin typeface="Calibri"/>
+              </a:rPr>
+              <a:t>6. ALERTAS DE UMBRAL — PROPONER EN LA REUNIÓN</a:t>
+            </a:r>
+          </a:p>
+        </p:txBody>
+      </p:sp>
+      <p:sp>
+        <p:nvSpPr>
+          <p:cNvPr id="22" name="TextBox 21"/>
+          <p:cNvSpPr txBox="1"/>
+          <p:nvPr/>
+        </p:nvSpPr>
+        <p:spPr>
+          <a:xfrm>
+            <a:off x="347472" y="5120640"/>
+            <a:ext cx="11430000" cy="768096"/>
+          </a:xfrm>
+          <a:prstGeom prst="rect">
+            <a:avLst/>
+          </a:prstGeom>
+          <a:noFill/>
+        </p:spPr>
+        <p:txBody>
+          <a:bodyPr wrap="square">
+            <a:spAutoFit/>
+          </a:bodyPr>
+          <a:lstStyle/>
+          <a:p>
+            <a:pPr algn="l">
+              <a:spcAft>
+                <a:spcPts val="200"/>
+              </a:spcAft>
+            </a:pPr>
+            <a:r>
+              <a:rPr sz="1000" b="0">
+                <a:solidFill>
+                  <a:srgbClr val="0D3B66"/>
+                </a:solidFill>
+                <a:latin typeface="Calibri"/>
+              </a:rPr>
+              <a:t>• Placa Bancaria (000025-08): umbral diario 155 m³/día (agosto ~123 × 1,25). El 18/06 llegó a ~410; WES avisa si se repite el salto, sin usar la media inflada de junio.</a:t>
+            </a:r>
+          </a:p>
+          <a:p>
+            <a:pPr algn="l">
+              <a:spcAft>
+                <a:spcPts val="200"/>
+              </a:spcAft>
+            </a:pPr>
+            <a:r>
+              <a:rPr sz="1000" b="0">
+                <a:solidFill>
+                  <a:srgbClr val="0D3B66"/>
+                </a:solidFill>
+                <a:latin typeface="Calibri"/>
+              </a:rPr>
+              <a:t>• Ripley (000025-10): umbral diario 125 m³/día (promedio ~99 × 1,25). Segundo volumen del recinto; noches ya ~0. Falabella: aún sin umbral fijo (2–3 semanas de baseline).</a:t>
+            </a:r>
+          </a:p>
+        </p:txBody>
+      </p:sp>
+      <p:sp>
+        <p:nvSpPr>
+          <p:cNvPr id="23" name="Rounded Rectangle 22"/>
+          <p:cNvSpPr/>
+          <p:nvPr/>
+        </p:nvSpPr>
+        <p:spPr>
+          <a:xfrm>
+            <a:off x="228600" y="6016752"/>
+            <a:ext cx="11704320" cy="731520"/>
           </a:xfrm>
           <a:prstGeom prst="roundRect">
             <a:avLst>
@@ -7948,13 +9347,13 @@
       </p:sp>
       <p:sp>
         <p:nvSpPr>
-          <p:cNvPr id="21" name="TextBox 20"/>
+          <p:cNvPr id="24" name="TextBox 23"/>
           <p:cNvSpPr txBox="1"/>
           <p:nvPr/>
         </p:nvSpPr>
         <p:spPr>
           <a:xfrm>
-            <a:off x="347472" y="5486400"/>
+            <a:off x="347472" y="6035040"/>
             <a:ext cx="11430000" cy="256032"/>
           </a:xfrm>
           <a:prstGeom prst="rect">
@@ -7987,14 +9386,14 @@
       </p:sp>
       <p:sp>
         <p:nvSpPr>
-          <p:cNvPr id="22" name="TextBox 21"/>
+          <p:cNvPr id="25" name="TextBox 24"/>
           <p:cNvSpPr txBox="1"/>
           <p:nvPr/>
         </p:nvSpPr>
         <p:spPr>
           <a:xfrm>
-            <a:off x="347472" y="5742432"/>
-            <a:ext cx="11430000" cy="896112"/>
+            <a:off x="347472" y="6272784"/>
+            <a:ext cx="11430000" cy="438912"/>
           </a:xfrm>
           <a:prstGeom prst="rect">
             <a:avLst/>
@@ -8013,7 +9412,7 @@
               </a:spcAft>
             </a:pPr>
             <a:r>
-              <a:rPr sz="1100" b="0">
+              <a:rPr sz="1000" b="0">
                 <a:solidFill>
                   <a:srgbClr val="0D3B66"/>
                 </a:solidFill>
@@ -8029,7 +9428,7 @@
               </a:spcAft>
             </a:pPr>
             <a:r>
-              <a:rPr sz="1100" b="0">
+              <a:rPr sz="1000" b="0">
                 <a:solidFill>
                   <a:srgbClr val="0D3B66"/>
                 </a:solidFill>
@@ -8045,7 +9444,7 @@
               </a:spcAft>
             </a:pPr>
             <a:r>
-              <a:rPr sz="1100" b="0">
+              <a:rPr sz="1000" b="0">
                 <a:solidFill>
                   <a:srgbClr val="0D3B66"/>
                 </a:solidFill>
@@ -8271,7 +9670,7 @@
         <p:spPr>
           <a:xfrm>
             <a:off x="228600" y="1024128"/>
-            <a:ext cx="3977639" cy="2331720"/>
+            <a:ext cx="3977639" cy="2212848"/>
           </a:xfrm>
           <a:prstGeom prst="roundRect">
             <a:avLst>
@@ -8315,7 +9714,7 @@
         </p:nvSpPr>
         <p:spPr>
           <a:xfrm>
-            <a:off x="347472" y="1078992"/>
+            <a:off x="347472" y="1060704"/>
             <a:ext cx="3749039" cy="256032"/>
           </a:xfrm>
           <a:prstGeom prst="rect">
@@ -8354,8 +9753,8 @@
         </p:nvSpPr>
         <p:spPr>
           <a:xfrm>
-            <a:off x="347472" y="1353312"/>
-            <a:ext cx="3749039" cy="1920240"/>
+            <a:off x="347472" y="1316736"/>
+            <a:ext cx="3749039" cy="1847088"/>
           </a:xfrm>
           <a:prstGeom prst="rect">
             <a:avLst/>
@@ -8410,7 +9809,7 @@
         <p:spPr>
           <a:xfrm>
             <a:off x="4297680" y="1024128"/>
-            <a:ext cx="7635240" cy="2331720"/>
+            <a:ext cx="7635240" cy="2212848"/>
           </a:xfrm>
           <a:prstGeom prst="roundRect">
             <a:avLst>
@@ -8454,7 +9853,7 @@
         </p:nvSpPr>
         <p:spPr>
           <a:xfrm>
-            <a:off x="4434840" y="1078992"/>
+            <a:off x="4434840" y="1060704"/>
             <a:ext cx="3657600" cy="256032"/>
           </a:xfrm>
           <a:prstGeom prst="rect">
@@ -8493,8 +9892,8 @@
         </p:nvSpPr>
         <p:spPr>
           <a:xfrm>
-            <a:off x="4434840" y="1353312"/>
-            <a:ext cx="3611880" cy="1920240"/>
+            <a:off x="4434840" y="1316736"/>
+            <a:ext cx="3611880" cy="1847088"/>
           </a:xfrm>
           <a:prstGeom prst="rect">
             <a:avLst/>
@@ -8620,7 +10019,7 @@
         </p:blipFill>
         <p:spPr>
           <a:xfrm>
-            <a:off x="8138160" y="1325880"/>
+            <a:off x="8138160" y="1280160"/>
             <a:ext cx="3611880" cy="1488617"/>
           </a:xfrm>
           <a:prstGeom prst="rect">
@@ -8636,8 +10035,8 @@
         </p:nvSpPr>
         <p:spPr>
           <a:xfrm>
-            <a:off x="228600" y="3456432"/>
-            <a:ext cx="5852160" cy="1874519"/>
+            <a:off x="228600" y="3310128"/>
+            <a:ext cx="5852160" cy="1444752"/>
           </a:xfrm>
           <a:prstGeom prst="roundRect">
             <a:avLst>
@@ -8681,7 +10080,7 @@
         </p:nvSpPr>
         <p:spPr>
           <a:xfrm>
-            <a:off x="347472" y="3511296"/>
+            <a:off x="347472" y="3346704"/>
             <a:ext cx="5577840" cy="256032"/>
           </a:xfrm>
           <a:prstGeom prst="rect">
@@ -8720,8 +10119,8 @@
         </p:nvSpPr>
         <p:spPr>
           <a:xfrm>
-            <a:off x="347472" y="3785615"/>
-            <a:ext cx="5596128" cy="1481328"/>
+            <a:off x="347472" y="3602736"/>
+            <a:ext cx="5596128" cy="1097280"/>
           </a:xfrm>
           <a:prstGeom prst="rect">
             <a:avLst/>
@@ -8740,7 +10139,7 @@
               </a:spcAft>
             </a:pPr>
             <a:r>
-              <a:rPr sz="1000" b="0">
+              <a:rPr sz="900" b="0">
                 <a:solidFill>
                   <a:srgbClr val="0D3B66"/>
                 </a:solidFill>
@@ -8756,7 +10155,7 @@
               </a:spcAft>
             </a:pPr>
             <a:r>
-              <a:rPr sz="1000" b="0">
+              <a:rPr sz="900" b="0">
                 <a:solidFill>
                   <a:srgbClr val="0D3B66"/>
                 </a:solidFill>
@@ -8772,7 +10171,7 @@
               </a:spcAft>
             </a:pPr>
             <a:r>
-              <a:rPr sz="1000" b="0">
+              <a:rPr sz="900" b="0">
                 <a:solidFill>
                   <a:srgbClr val="0D3B66"/>
                 </a:solidFill>
@@ -8788,29 +10187,13 @@
               </a:spcAft>
             </a:pPr>
             <a:r>
-              <a:rPr sz="1000" b="0">
+              <a:rPr sz="900" b="0">
                 <a:solidFill>
                   <a:srgbClr val="0D3B66"/>
                 </a:solidFill>
                 <a:latin typeface="Calibri"/>
               </a:rPr>
               <a:t>• Alimentación Baños: bajo y estable (jun 102 / jul 62 / ago 49 m³); uso hábil.</a:t>
-            </a:r>
-          </a:p>
-          <a:p>
-            <a:pPr algn="l">
-              <a:spcAft>
-                <a:spcPts val="200"/>
-              </a:spcAft>
-            </a:pPr>
-            <a:r>
-              <a:rPr sz="1000" b="0">
-                <a:solidFill>
-                  <a:srgbClr val="0D3B66"/>
-                </a:solidFill>
-                <a:latin typeface="Calibri"/>
-              </a:rPr>
-              <a:t>• Red de Incendio (000025-14) relocalizada: 0 m³. No forma parte del activo.</a:t>
             </a:r>
           </a:p>
         </p:txBody>
@@ -8823,8 +10206,8 @@
         </p:nvSpPr>
         <p:spPr>
           <a:xfrm>
-            <a:off x="6217920" y="3456432"/>
-            <a:ext cx="5715000" cy="1874519"/>
+            <a:off x="6217920" y="3310128"/>
+            <a:ext cx="5715000" cy="1444752"/>
           </a:xfrm>
           <a:prstGeom prst="roundRect">
             <a:avLst>
@@ -8868,7 +10251,7 @@
         </p:nvSpPr>
         <p:spPr>
           <a:xfrm>
-            <a:off x="6336792" y="3511296"/>
+            <a:off x="6336792" y="3346704"/>
             <a:ext cx="5486400" cy="256032"/>
           </a:xfrm>
           <a:prstGeom prst="rect">
@@ -8907,8 +10290,8 @@
         </p:nvSpPr>
         <p:spPr>
           <a:xfrm>
-            <a:off x="6336792" y="3785615"/>
-            <a:ext cx="5468112" cy="1481328"/>
+            <a:off x="6336792" y="3602736"/>
+            <a:ext cx="5468112" cy="1097280"/>
           </a:xfrm>
           <a:prstGeom prst="rect">
             <a:avLst/>
@@ -8927,7 +10310,7 @@
               </a:spcAft>
             </a:pPr>
             <a:r>
-              <a:rPr sz="1000" b="0">
+              <a:rPr sz="900" b="0">
                 <a:solidFill>
                   <a:srgbClr val="0D3B66"/>
                 </a:solidFill>
@@ -8943,7 +10326,7 @@
               </a:spcAft>
             </a:pPr>
             <a:r>
-              <a:rPr sz="1000" b="0">
+              <a:rPr sz="900" b="0">
                 <a:solidFill>
                   <a:srgbClr val="0D3B66"/>
                 </a:solidFill>
@@ -8959,7 +10342,7 @@
               </a:spcAft>
             </a:pPr>
             <a:r>
-              <a:rPr sz="1000" b="0">
+              <a:rPr sz="900" b="0">
                 <a:solidFill>
                   <a:srgbClr val="0D3B66"/>
                 </a:solidFill>
@@ -8978,8 +10361,149 @@
         </p:nvSpPr>
         <p:spPr>
           <a:xfrm>
-            <a:off x="228600" y="5440680"/>
-            <a:ext cx="11704320" cy="1261872"/>
+            <a:off x="228600" y="4828032"/>
+            <a:ext cx="11704320" cy="1115568"/>
+          </a:xfrm>
+          <a:prstGeom prst="roundRect">
+            <a:avLst>
+              <a:gd name="adj" fmla="val 8000"/>
+            </a:avLst>
+          </a:prstGeom>
+          <a:solidFill>
+            <a:srgbClr val="E8F4F8"/>
+          </a:solidFill>
+          <a:ln w="6350">
+            <a:solidFill>
+              <a:srgbClr val="1F77B4"/>
+            </a:solidFill>
+          </a:ln>
+        </p:spPr>
+        <p:style>
+          <a:lnRef idx="1">
+            <a:schemeClr val="accent1"/>
+          </a:lnRef>
+          <a:fillRef idx="3">
+            <a:schemeClr val="accent1"/>
+          </a:fillRef>
+          <a:effectRef idx="2">
+            <a:schemeClr val="accent1"/>
+          </a:effectRef>
+          <a:fontRef idx="minor">
+            <a:schemeClr val="lt1"/>
+          </a:fontRef>
+        </p:style>
+        <p:txBody>
+          <a:bodyPr rtlCol="0" anchor="ctr"/>
+          <a:lstStyle/>
+          <a:p>
+            <a:pPr algn="ctr"/>
+          </a:p>
+        </p:txBody>
+      </p:sp>
+      <p:sp>
+        <p:nvSpPr>
+          <p:cNvPr id="21" name="TextBox 20"/>
+          <p:cNvSpPr txBox="1"/>
+          <p:nvPr/>
+        </p:nvSpPr>
+        <p:spPr>
+          <a:xfrm>
+            <a:off x="347472" y="4864608"/>
+            <a:ext cx="11430000" cy="256032"/>
+          </a:xfrm>
+          <a:prstGeom prst="rect">
+            <a:avLst/>
+          </a:prstGeom>
+          <a:noFill/>
+        </p:spPr>
+        <p:txBody>
+          <a:bodyPr wrap="square">
+            <a:spAutoFit/>
+          </a:bodyPr>
+          <a:lstStyle/>
+          <a:p>
+            <a:pPr algn="l">
+              <a:spcAft>
+                <a:spcPts val="200"/>
+              </a:spcAft>
+            </a:pPr>
+            <a:r>
+              <a:rPr sz="1100" b="1">
+                <a:solidFill>
+                  <a:srgbClr val="1F77B4"/>
+                </a:solidFill>
+                <a:latin typeface="Calibri"/>
+              </a:rPr>
+              <a:t>6. ALERTAS DE UMBRAL — PROPONER EN LA REUNIÓN</a:t>
+            </a:r>
+          </a:p>
+        </p:txBody>
+      </p:sp>
+      <p:sp>
+        <p:nvSpPr>
+          <p:cNvPr id="22" name="TextBox 21"/>
+          <p:cNvSpPr txBox="1"/>
+          <p:nvPr/>
+        </p:nvSpPr>
+        <p:spPr>
+          <a:xfrm>
+            <a:off x="347472" y="5120640"/>
+            <a:ext cx="11430000" cy="768096"/>
+          </a:xfrm>
+          <a:prstGeom prst="rect">
+            <a:avLst/>
+          </a:prstGeom>
+          <a:noFill/>
+        </p:spPr>
+        <p:txBody>
+          <a:bodyPr wrap="square">
+            <a:spAutoFit/>
+          </a:bodyPr>
+          <a:lstStyle/>
+          <a:p>
+            <a:pPr algn="l">
+              <a:spcAft>
+                <a:spcPts val="200"/>
+              </a:spcAft>
+            </a:pPr>
+            <a:r>
+              <a:rPr sz="1000" b="0">
+                <a:solidFill>
+                  <a:srgbClr val="0D3B66"/>
+                </a:solidFill>
+                <a:latin typeface="Calibri"/>
+              </a:rPr>
+              <a:t>• Matriz Principal (000025-13) — nocturno: alerta si 00:00–06:00 &gt; 8 m³ (hoy 21–26 m³). Es lo que hay que ver en sala hasta que exista on/off.</a:t>
+            </a:r>
+          </a:p>
+          <a:p>
+            <a:pPr algn="l">
+              <a:spcAft>
+                <a:spcPts val="200"/>
+              </a:spcAft>
+            </a:pPr>
+            <a:r>
+              <a:rPr sz="1000" b="0">
+                <a:solidFill>
+                  <a:srgbClr val="0D3B66"/>
+                </a:solidFill>
+                <a:latin typeface="Calibri"/>
+              </a:rPr>
+              <a:t>• Matriz Principal — diario: umbral 230 m³/día (mediana ~187 × 1,25). Agosto ~202; avisa si el alza jun→ago sigue. Baños: no priorizar.</a:t>
+            </a:r>
+          </a:p>
+        </p:txBody>
+      </p:sp>
+      <p:sp>
+        <p:nvSpPr>
+          <p:cNvPr id="23" name="Rounded Rectangle 22"/>
+          <p:cNvSpPr/>
+          <p:nvPr/>
+        </p:nvSpPr>
+        <p:spPr>
+          <a:xfrm>
+            <a:off x="228600" y="6016752"/>
+            <a:ext cx="11704320" cy="731520"/>
           </a:xfrm>
           <a:prstGeom prst="roundRect">
             <a:avLst>
@@ -9019,13 +10543,13 @@
       </p:sp>
       <p:sp>
         <p:nvSpPr>
-          <p:cNvPr id="21" name="TextBox 20"/>
+          <p:cNvPr id="24" name="TextBox 23"/>
           <p:cNvSpPr txBox="1"/>
           <p:nvPr/>
         </p:nvSpPr>
         <p:spPr>
           <a:xfrm>
-            <a:off x="347472" y="5486400"/>
+            <a:off x="347472" y="6035040"/>
             <a:ext cx="11430000" cy="256032"/>
           </a:xfrm>
           <a:prstGeom prst="rect">
@@ -9058,14 +10582,14 @@
       </p:sp>
       <p:sp>
         <p:nvSpPr>
-          <p:cNvPr id="22" name="TextBox 21"/>
+          <p:cNvPr id="25" name="TextBox 24"/>
           <p:cNvSpPr txBox="1"/>
           <p:nvPr/>
         </p:nvSpPr>
         <p:spPr>
           <a:xfrm>
-            <a:off x="347472" y="5742432"/>
-            <a:ext cx="11430000" cy="896112"/>
+            <a:off x="347472" y="6272784"/>
+            <a:ext cx="11430000" cy="438912"/>
           </a:xfrm>
           <a:prstGeom prst="rect">
             <a:avLst/>
@@ -9084,7 +10608,7 @@
               </a:spcAft>
             </a:pPr>
             <a:r>
-              <a:rPr sz="1100" b="0">
+              <a:rPr sz="1000" b="0">
                 <a:solidFill>
                   <a:srgbClr val="0D3B66"/>
                 </a:solidFill>
@@ -9100,7 +10624,7 @@
               </a:spcAft>
             </a:pPr>
             <a:r>
-              <a:rPr sz="1100" b="0">
+              <a:rPr sz="1000" b="0">
                 <a:solidFill>
                   <a:srgbClr val="0D3B66"/>
                 </a:solidFill>
@@ -9326,7 +10850,7 @@
         <p:spPr>
           <a:xfrm>
             <a:off x="228600" y="1024128"/>
-            <a:ext cx="3977639" cy="2331720"/>
+            <a:ext cx="3977639" cy="2212848"/>
           </a:xfrm>
           <a:prstGeom prst="roundRect">
             <a:avLst>
@@ -9370,7 +10894,7 @@
         </p:nvSpPr>
         <p:spPr>
           <a:xfrm>
-            <a:off x="347472" y="1078992"/>
+            <a:off x="347472" y="1060704"/>
             <a:ext cx="3749039" cy="256032"/>
           </a:xfrm>
           <a:prstGeom prst="rect">
@@ -9409,8 +10933,8 @@
         </p:nvSpPr>
         <p:spPr>
           <a:xfrm>
-            <a:off x="347472" y="1353312"/>
-            <a:ext cx="3749039" cy="1920240"/>
+            <a:off x="347472" y="1316736"/>
+            <a:ext cx="3749039" cy="1847088"/>
           </a:xfrm>
           <a:prstGeom prst="rect">
             <a:avLst/>
@@ -9465,7 +10989,7 @@
         <p:spPr>
           <a:xfrm>
             <a:off x="4297680" y="1024128"/>
-            <a:ext cx="7635240" cy="2331720"/>
+            <a:ext cx="7635240" cy="2212848"/>
           </a:xfrm>
           <a:prstGeom prst="roundRect">
             <a:avLst>
@@ -9509,7 +11033,7 @@
         </p:nvSpPr>
         <p:spPr>
           <a:xfrm>
-            <a:off x="4434840" y="1078992"/>
+            <a:off x="4434840" y="1060704"/>
             <a:ext cx="3657600" cy="256032"/>
           </a:xfrm>
           <a:prstGeom prst="rect">
@@ -9548,8 +11072,8 @@
         </p:nvSpPr>
         <p:spPr>
           <a:xfrm>
-            <a:off x="4434840" y="1353312"/>
-            <a:ext cx="3611880" cy="1920240"/>
+            <a:off x="4434840" y="1316736"/>
+            <a:ext cx="3611880" cy="1847088"/>
           </a:xfrm>
           <a:prstGeom prst="rect">
             <a:avLst/>
@@ -9675,7 +11199,7 @@
         </p:blipFill>
         <p:spPr>
           <a:xfrm>
-            <a:off x="8138160" y="1325880"/>
+            <a:off x="8138160" y="1280160"/>
             <a:ext cx="3611880" cy="1488617"/>
           </a:xfrm>
           <a:prstGeom prst="rect">
@@ -9691,8 +11215,8 @@
         </p:nvSpPr>
         <p:spPr>
           <a:xfrm>
-            <a:off x="228600" y="3456432"/>
-            <a:ext cx="5852160" cy="1874519"/>
+            <a:off x="228600" y="3310128"/>
+            <a:ext cx="5852160" cy="1444752"/>
           </a:xfrm>
           <a:prstGeom prst="roundRect">
             <a:avLst>
@@ -9736,7 +11260,7 @@
         </p:nvSpPr>
         <p:spPr>
           <a:xfrm>
-            <a:off x="347472" y="3511296"/>
+            <a:off x="347472" y="3346704"/>
             <a:ext cx="5577840" cy="256032"/>
           </a:xfrm>
           <a:prstGeom prst="rect">
@@ -9775,8 +11299,8 @@
         </p:nvSpPr>
         <p:spPr>
           <a:xfrm>
-            <a:off x="347472" y="3785615"/>
-            <a:ext cx="5596128" cy="1481328"/>
+            <a:off x="347472" y="3602736"/>
+            <a:ext cx="5596128" cy="1097280"/>
           </a:xfrm>
           <a:prstGeom prst="rect">
             <a:avLst/>
@@ -9795,7 +11319,7 @@
               </a:spcAft>
             </a:pPr>
             <a:r>
-              <a:rPr sz="1000" b="0">
+              <a:rPr sz="900" b="0">
                 <a:solidFill>
                   <a:srgbClr val="0D3B66"/>
                 </a:solidFill>
@@ -9811,7 +11335,7 @@
               </a:spcAft>
             </a:pPr>
             <a:r>
-              <a:rPr sz="1000" b="0">
+              <a:rPr sz="900" b="0">
                 <a:solidFill>
                   <a:srgbClr val="0D3B66"/>
                 </a:solidFill>
@@ -9827,7 +11351,7 @@
               </a:spcAft>
             </a:pPr>
             <a:r>
-              <a:rPr sz="1000" b="0">
+              <a:rPr sz="900" b="0">
                 <a:solidFill>
                   <a:srgbClr val="0D3B66"/>
                 </a:solidFill>
@@ -9843,7 +11367,7 @@
               </a:spcAft>
             </a:pPr>
             <a:r>
-              <a:rPr sz="1000" b="0">
+              <a:rPr sz="900" b="0">
                 <a:solidFill>
                   <a:srgbClr val="0D3B66"/>
                 </a:solidFill>
@@ -9862,8 +11386,8 @@
         </p:nvSpPr>
         <p:spPr>
           <a:xfrm>
-            <a:off x="6217920" y="3456432"/>
-            <a:ext cx="5715000" cy="1874519"/>
+            <a:off x="6217920" y="3310128"/>
+            <a:ext cx="5715000" cy="1444752"/>
           </a:xfrm>
           <a:prstGeom prst="roundRect">
             <a:avLst>
@@ -9907,7 +11431,7 @@
         </p:nvSpPr>
         <p:spPr>
           <a:xfrm>
-            <a:off x="6336792" y="3511296"/>
+            <a:off x="6336792" y="3346704"/>
             <a:ext cx="5486400" cy="256032"/>
           </a:xfrm>
           <a:prstGeom prst="rect">
@@ -9946,8 +11470,8 @@
         </p:nvSpPr>
         <p:spPr>
           <a:xfrm>
-            <a:off x="6336792" y="3785615"/>
-            <a:ext cx="5468112" cy="1481328"/>
+            <a:off x="6336792" y="3602736"/>
+            <a:ext cx="5468112" cy="1097280"/>
           </a:xfrm>
           <a:prstGeom prst="rect">
             <a:avLst/>
@@ -9966,7 +11490,7 @@
               </a:spcAft>
             </a:pPr>
             <a:r>
-              <a:rPr sz="1000" b="0">
+              <a:rPr sz="900" b="0">
                 <a:solidFill>
                   <a:srgbClr val="0D3B66"/>
                 </a:solidFill>
@@ -9982,7 +11506,7 @@
               </a:spcAft>
             </a:pPr>
             <a:r>
-              <a:rPr sz="1000" b="0">
+              <a:rPr sz="900" b="0">
                 <a:solidFill>
                   <a:srgbClr val="0D3B66"/>
                 </a:solidFill>
@@ -9998,7 +11522,7 @@
               </a:spcAft>
             </a:pPr>
             <a:r>
-              <a:rPr sz="1000" b="0">
+              <a:rPr sz="900" b="0">
                 <a:solidFill>
                   <a:srgbClr val="0D3B66"/>
                 </a:solidFill>
@@ -10017,8 +11541,149 @@
         </p:nvSpPr>
         <p:spPr>
           <a:xfrm>
-            <a:off x="228600" y="5440680"/>
-            <a:ext cx="11704320" cy="1261872"/>
+            <a:off x="228600" y="4828032"/>
+            <a:ext cx="11704320" cy="1115568"/>
+          </a:xfrm>
+          <a:prstGeom prst="roundRect">
+            <a:avLst>
+              <a:gd name="adj" fmla="val 8000"/>
+            </a:avLst>
+          </a:prstGeom>
+          <a:solidFill>
+            <a:srgbClr val="E8F4F8"/>
+          </a:solidFill>
+          <a:ln w="6350">
+            <a:solidFill>
+              <a:srgbClr val="1F77B4"/>
+            </a:solidFill>
+          </a:ln>
+        </p:spPr>
+        <p:style>
+          <a:lnRef idx="1">
+            <a:schemeClr val="accent1"/>
+          </a:lnRef>
+          <a:fillRef idx="3">
+            <a:schemeClr val="accent1"/>
+          </a:fillRef>
+          <a:effectRef idx="2">
+            <a:schemeClr val="accent1"/>
+          </a:effectRef>
+          <a:fontRef idx="minor">
+            <a:schemeClr val="lt1"/>
+          </a:fontRef>
+        </p:style>
+        <p:txBody>
+          <a:bodyPr rtlCol="0" anchor="ctr"/>
+          <a:lstStyle/>
+          <a:p>
+            <a:pPr algn="ctr"/>
+          </a:p>
+        </p:txBody>
+      </p:sp>
+      <p:sp>
+        <p:nvSpPr>
+          <p:cNvPr id="21" name="TextBox 20"/>
+          <p:cNvSpPr txBox="1"/>
+          <p:nvPr/>
+        </p:nvSpPr>
+        <p:spPr>
+          <a:xfrm>
+            <a:off x="347472" y="4864608"/>
+            <a:ext cx="11430000" cy="256032"/>
+          </a:xfrm>
+          <a:prstGeom prst="rect">
+            <a:avLst/>
+          </a:prstGeom>
+          <a:noFill/>
+        </p:spPr>
+        <p:txBody>
+          <a:bodyPr wrap="square">
+            <a:spAutoFit/>
+          </a:bodyPr>
+          <a:lstStyle/>
+          <a:p>
+            <a:pPr algn="l">
+              <a:spcAft>
+                <a:spcPts val="200"/>
+              </a:spcAft>
+            </a:pPr>
+            <a:r>
+              <a:rPr sz="1100" b="1">
+                <a:solidFill>
+                  <a:srgbClr val="1F77B4"/>
+                </a:solidFill>
+                <a:latin typeface="Calibri"/>
+              </a:rPr>
+              <a:t>6. ALERTAS DE UMBRAL — PROPONER EN LA REUNIÓN</a:t>
+            </a:r>
+          </a:p>
+        </p:txBody>
+      </p:sp>
+      <p:sp>
+        <p:nvSpPr>
+          <p:cNvPr id="22" name="TextBox 21"/>
+          <p:cNvSpPr txBox="1"/>
+          <p:nvPr/>
+        </p:nvSpPr>
+        <p:spPr>
+          <a:xfrm>
+            <a:off x="347472" y="5120640"/>
+            <a:ext cx="11430000" cy="768096"/>
+          </a:xfrm>
+          <a:prstGeom prst="rect">
+            <a:avLst/>
+          </a:prstGeom>
+          <a:noFill/>
+        </p:spPr>
+        <p:txBody>
+          <a:bodyPr wrap="square">
+            <a:spAutoFit/>
+          </a:bodyPr>
+          <a:lstStyle/>
+          <a:p>
+            <a:pPr algn="l">
+              <a:spcAft>
+                <a:spcPts val="200"/>
+              </a:spcAft>
+            </a:pPr>
+            <a:r>
+              <a:rPr sz="1000" b="0">
+                <a:solidFill>
+                  <a:srgbClr val="0D3B66"/>
+                </a:solidFill>
+                <a:latin typeface="Calibri"/>
+              </a:rPr>
+              <a:t>• San Ignacio 500 (000025-18) — diario: umbral 145 m³/día (agosto ~116 × 1,25). La noche ya está controlada; el umbral vigila el caudal diurno que no volvió a junio.</a:t>
+            </a:r>
+          </a:p>
+          <a:p>
+            <a:pPr algn="l">
+              <a:spcAft>
+                <a:spcPts val="200"/>
+              </a:spcAft>
+            </a:pPr>
+            <a:r>
+              <a:rPr sz="1000" b="0">
+                <a:solidFill>
+                  <a:srgbClr val="0D3B66"/>
+                </a:solidFill>
+                <a:latin typeface="Calibri"/>
+              </a:rPr>
+              <a:t>• San Ignacio 300 (000025-17) — nocturno: alerta si 00:00–06:00 &gt; 4 m³ (el 10/08 fueron ~10 m³, ~51% del día). Sin control: esta es la alerta de madrugada del recinto.</a:t>
+            </a:r>
+          </a:p>
+        </p:txBody>
+      </p:sp>
+      <p:sp>
+        <p:nvSpPr>
+          <p:cNvPr id="23" name="Rounded Rectangle 22"/>
+          <p:cNvSpPr/>
+          <p:nvPr/>
+        </p:nvSpPr>
+        <p:spPr>
+          <a:xfrm>
+            <a:off x="228600" y="6016752"/>
+            <a:ext cx="11704320" cy="731520"/>
           </a:xfrm>
           <a:prstGeom prst="roundRect">
             <a:avLst>
@@ -10058,13 +11723,13 @@
       </p:sp>
       <p:sp>
         <p:nvSpPr>
-          <p:cNvPr id="21" name="TextBox 20"/>
+          <p:cNvPr id="24" name="TextBox 23"/>
           <p:cNvSpPr txBox="1"/>
           <p:nvPr/>
         </p:nvSpPr>
         <p:spPr>
           <a:xfrm>
-            <a:off x="347472" y="5486400"/>
+            <a:off x="347472" y="6035040"/>
             <a:ext cx="11430000" cy="256032"/>
           </a:xfrm>
           <a:prstGeom prst="rect">
@@ -10097,14 +11762,14 @@
       </p:sp>
       <p:sp>
         <p:nvSpPr>
-          <p:cNvPr id="22" name="TextBox 21"/>
+          <p:cNvPr id="25" name="TextBox 24"/>
           <p:cNvSpPr txBox="1"/>
           <p:nvPr/>
         </p:nvSpPr>
         <p:spPr>
           <a:xfrm>
-            <a:off x="347472" y="5742432"/>
-            <a:ext cx="11430000" cy="896112"/>
+            <a:off x="347472" y="6272784"/>
+            <a:ext cx="11430000" cy="438912"/>
           </a:xfrm>
           <a:prstGeom prst="rect">
             <a:avLst/>
@@ -10123,7 +11788,7 @@
               </a:spcAft>
             </a:pPr>
             <a:r>
-              <a:rPr sz="1100" b="0">
+              <a:rPr sz="1000" b="0">
                 <a:solidFill>
                   <a:srgbClr val="0D3B66"/>
                 </a:solidFill>
@@ -10139,7 +11804,7 @@
               </a:spcAft>
             </a:pPr>
             <a:r>
-              <a:rPr sz="1100" b="0">
+              <a:rPr sz="1000" b="0">
                 <a:solidFill>
                   <a:srgbClr val="0D3B66"/>
                 </a:solidFill>
@@ -10365,7 +12030,7 @@
         <p:spPr>
           <a:xfrm>
             <a:off x="228600" y="1024128"/>
-            <a:ext cx="3977639" cy="2331720"/>
+            <a:ext cx="3977639" cy="2212848"/>
           </a:xfrm>
           <a:prstGeom prst="roundRect">
             <a:avLst>
@@ -10409,7 +12074,7 @@
         </p:nvSpPr>
         <p:spPr>
           <a:xfrm>
-            <a:off x="347472" y="1078992"/>
+            <a:off x="347472" y="1060704"/>
             <a:ext cx="3749039" cy="256032"/>
           </a:xfrm>
           <a:prstGeom prst="rect">
@@ -10448,8 +12113,8 @@
         </p:nvSpPr>
         <p:spPr>
           <a:xfrm>
-            <a:off x="347472" y="1353312"/>
-            <a:ext cx="3749039" cy="1920240"/>
+            <a:off x="347472" y="1316736"/>
+            <a:ext cx="3749039" cy="1847088"/>
           </a:xfrm>
           <a:prstGeom prst="rect">
             <a:avLst/>
@@ -10504,7 +12169,7 @@
         <p:spPr>
           <a:xfrm>
             <a:off x="4297680" y="1024128"/>
-            <a:ext cx="7635240" cy="2331720"/>
+            <a:ext cx="7635240" cy="2212848"/>
           </a:xfrm>
           <a:prstGeom prst="roundRect">
             <a:avLst>
@@ -10548,7 +12213,7 @@
         </p:nvSpPr>
         <p:spPr>
           <a:xfrm>
-            <a:off x="4434840" y="1078992"/>
+            <a:off x="4434840" y="1060704"/>
             <a:ext cx="3657600" cy="256032"/>
           </a:xfrm>
           <a:prstGeom prst="rect">
@@ -10587,8 +12252,8 @@
         </p:nvSpPr>
         <p:spPr>
           <a:xfrm>
-            <a:off x="4434840" y="1353312"/>
-            <a:ext cx="3611880" cy="1920240"/>
+            <a:off x="4434840" y="1316736"/>
+            <a:ext cx="3611880" cy="1847088"/>
           </a:xfrm>
           <a:prstGeom prst="rect">
             <a:avLst/>
@@ -10714,7 +12379,7 @@
         </p:blipFill>
         <p:spPr>
           <a:xfrm>
-            <a:off x="8138160" y="1325880"/>
+            <a:off x="8138160" y="1280160"/>
             <a:ext cx="3611880" cy="1488617"/>
           </a:xfrm>
           <a:prstGeom prst="rect">
@@ -10730,8 +12395,8 @@
         </p:nvSpPr>
         <p:spPr>
           <a:xfrm>
-            <a:off x="228600" y="3456432"/>
-            <a:ext cx="5852160" cy="1874519"/>
+            <a:off x="228600" y="3310128"/>
+            <a:ext cx="5852160" cy="1444752"/>
           </a:xfrm>
           <a:prstGeom prst="roundRect">
             <a:avLst>
@@ -10775,7 +12440,7 @@
         </p:nvSpPr>
         <p:spPr>
           <a:xfrm>
-            <a:off x="347472" y="3511296"/>
+            <a:off x="347472" y="3346704"/>
             <a:ext cx="5577840" cy="256032"/>
           </a:xfrm>
           <a:prstGeom prst="rect">
@@ -10814,8 +12479,8 @@
         </p:nvSpPr>
         <p:spPr>
           <a:xfrm>
-            <a:off x="347472" y="3785615"/>
-            <a:ext cx="5596128" cy="1481328"/>
+            <a:off x="347472" y="3602736"/>
+            <a:ext cx="5596128" cy="1097280"/>
           </a:xfrm>
           <a:prstGeom prst="rect">
             <a:avLst/>
@@ -10834,7 +12499,7 @@
               </a:spcAft>
             </a:pPr>
             <a:r>
-              <a:rPr sz="1000" b="0">
+              <a:rPr sz="900" b="0">
                 <a:solidFill>
                   <a:srgbClr val="0D3B66"/>
                 </a:solidFill>
@@ -10850,7 +12515,7 @@
               </a:spcAft>
             </a:pPr>
             <a:r>
-              <a:rPr sz="1000" b="0">
+              <a:rPr sz="900" b="0">
                 <a:solidFill>
                   <a:srgbClr val="0D3B66"/>
                 </a:solidFill>
@@ -10866,7 +12531,7 @@
               </a:spcAft>
             </a:pPr>
             <a:r>
-              <a:rPr sz="1000" b="0">
+              <a:rPr sz="900" b="0">
                 <a:solidFill>
                   <a:srgbClr val="0D3B66"/>
                 </a:solidFill>
@@ -10882,29 +12547,13 @@
               </a:spcAft>
             </a:pPr>
             <a:r>
-              <a:rPr sz="1000" b="0">
+              <a:rPr sz="900" b="0">
                 <a:solidFill>
                   <a:srgbClr val="0D3B66"/>
                 </a:solidFill>
                 <a:latin typeface="Calibri"/>
               </a:rPr>
               <a:t>• Anillo Plaza: jul 646,7 m³ (alza vs jun 464,7); 10/08 noche 2,3 de 12,2 m³.</a:t>
-            </a:r>
-          </a:p>
-          <a:p>
-            <a:pPr algn="l">
-              <a:spcAft>
-                <a:spcPts val="200"/>
-              </a:spcAft>
-            </a:pPr>
-            <a:r>
-              <a:rPr sz="1000" b="0">
-                <a:solidFill>
-                  <a:srgbClr val="0D3B66"/>
-                </a:solidFill>
-                <a:latin typeface="Calibri"/>
-              </a:rPr>
-              <a:t>• La portada del deck 7 Malls aún nombra Matriz A.A.; el dato activo es 000025-11.</a:t>
             </a:r>
           </a:p>
         </p:txBody>
@@ -10917,8 +12566,8 @@
         </p:nvSpPr>
         <p:spPr>
           <a:xfrm>
-            <a:off x="6217920" y="3456432"/>
-            <a:ext cx="5715000" cy="1874519"/>
+            <a:off x="6217920" y="3310128"/>
+            <a:ext cx="5715000" cy="1444752"/>
           </a:xfrm>
           <a:prstGeom prst="roundRect">
             <a:avLst>
@@ -10962,7 +12611,7 @@
         </p:nvSpPr>
         <p:spPr>
           <a:xfrm>
-            <a:off x="6336792" y="3511296"/>
+            <a:off x="6336792" y="3346704"/>
             <a:ext cx="5486400" cy="256032"/>
           </a:xfrm>
           <a:prstGeom prst="rect">
@@ -11001,8 +12650,8 @@
         </p:nvSpPr>
         <p:spPr>
           <a:xfrm>
-            <a:off x="6336792" y="3785615"/>
-            <a:ext cx="5468112" cy="1481328"/>
+            <a:off x="6336792" y="3602736"/>
+            <a:ext cx="5468112" cy="1097280"/>
           </a:xfrm>
           <a:prstGeom prst="rect">
             <a:avLst/>
@@ -11021,7 +12670,7 @@
               </a:spcAft>
             </a:pPr>
             <a:r>
-              <a:rPr sz="1000" b="0">
+              <a:rPr sz="900" b="0">
                 <a:solidFill>
                   <a:srgbClr val="0D3B66"/>
                 </a:solidFill>
@@ -11037,7 +12686,7 @@
               </a:spcAft>
             </a:pPr>
             <a:r>
-              <a:rPr sz="1000" b="0">
+              <a:rPr sz="900" b="0">
                 <a:solidFill>
                   <a:srgbClr val="0D3B66"/>
                 </a:solidFill>
@@ -11053,7 +12702,7 @@
               </a:spcAft>
             </a:pPr>
             <a:r>
-              <a:rPr sz="1000" b="0">
+              <a:rPr sz="900" b="0">
                 <a:solidFill>
                   <a:srgbClr val="0D3B66"/>
                 </a:solidFill>
@@ -11072,8 +12721,149 @@
         </p:nvSpPr>
         <p:spPr>
           <a:xfrm>
-            <a:off x="228600" y="5440680"/>
-            <a:ext cx="11704320" cy="1261872"/>
+            <a:off x="228600" y="4828032"/>
+            <a:ext cx="11704320" cy="1115568"/>
+          </a:xfrm>
+          <a:prstGeom prst="roundRect">
+            <a:avLst>
+              <a:gd name="adj" fmla="val 8000"/>
+            </a:avLst>
+          </a:prstGeom>
+          <a:solidFill>
+            <a:srgbClr val="E8F4F8"/>
+          </a:solidFill>
+          <a:ln w="6350">
+            <a:solidFill>
+              <a:srgbClr val="1F77B4"/>
+            </a:solidFill>
+          </a:ln>
+        </p:spPr>
+        <p:style>
+          <a:lnRef idx="1">
+            <a:schemeClr val="accent1"/>
+          </a:lnRef>
+          <a:fillRef idx="3">
+            <a:schemeClr val="accent1"/>
+          </a:fillRef>
+          <a:effectRef idx="2">
+            <a:schemeClr val="accent1"/>
+          </a:effectRef>
+          <a:fontRef idx="minor">
+            <a:schemeClr val="lt1"/>
+          </a:fontRef>
+        </p:style>
+        <p:txBody>
+          <a:bodyPr rtlCol="0" anchor="ctr"/>
+          <a:lstStyle/>
+          <a:p>
+            <a:pPr algn="ctr"/>
+          </a:p>
+        </p:txBody>
+      </p:sp>
+      <p:sp>
+        <p:nvSpPr>
+          <p:cNvPr id="21" name="TextBox 20"/>
+          <p:cNvSpPr txBox="1"/>
+          <p:nvPr/>
+        </p:nvSpPr>
+        <p:spPr>
+          <a:xfrm>
+            <a:off x="347472" y="4864608"/>
+            <a:ext cx="11430000" cy="256032"/>
+          </a:xfrm>
+          <a:prstGeom prst="rect">
+            <a:avLst/>
+          </a:prstGeom>
+          <a:noFill/>
+        </p:spPr>
+        <p:txBody>
+          <a:bodyPr wrap="square">
+            <a:spAutoFit/>
+          </a:bodyPr>
+          <a:lstStyle/>
+          <a:p>
+            <a:pPr algn="l">
+              <a:spcAft>
+                <a:spcPts val="200"/>
+              </a:spcAft>
+            </a:pPr>
+            <a:r>
+              <a:rPr sz="1100" b="1">
+                <a:solidFill>
+                  <a:srgbClr val="1F77B4"/>
+                </a:solidFill>
+                <a:latin typeface="Calibri"/>
+              </a:rPr>
+              <a:t>6. ALERTAS DE UMBRAL — PROPONER EN LA REUNIÓN</a:t>
+            </a:r>
+          </a:p>
+        </p:txBody>
+      </p:sp>
+      <p:sp>
+        <p:nvSpPr>
+          <p:cNvPr id="22" name="TextBox 21"/>
+          <p:cNvSpPr txBox="1"/>
+          <p:nvPr/>
+        </p:nvSpPr>
+        <p:spPr>
+          <a:xfrm>
+            <a:off x="347472" y="5120640"/>
+            <a:ext cx="11430000" cy="768096"/>
+          </a:xfrm>
+          <a:prstGeom prst="rect">
+            <a:avLst/>
+          </a:prstGeom>
+          <a:noFill/>
+        </p:spPr>
+        <p:txBody>
+          <a:bodyPr wrap="square">
+            <a:spAutoFit/>
+          </a:bodyPr>
+          <a:lstStyle/>
+          <a:p>
+            <a:pPr algn="l">
+              <a:spcAft>
+                <a:spcPts val="200"/>
+              </a:spcAft>
+            </a:pPr>
+            <a:r>
+              <a:rPr sz="1000" b="0">
+                <a:solidFill>
+                  <a:srgbClr val="0D3B66"/>
+                </a:solidFill>
+                <a:latin typeface="Calibri"/>
+              </a:rPr>
+              <a:t>• Matriz 1° piso (000025-11) — nocturno: alerta si 00:00–06:00 &gt; 3 m³ (el 10/08 = 6,5 m³). De día está estable (~56 m³); la madrugada es lo que hay que gestionar.</a:t>
+            </a:r>
+          </a:p>
+          <a:p>
+            <a:pPr algn="l">
+              <a:spcAft>
+                <a:spcPts val="200"/>
+              </a:spcAft>
+            </a:pPr>
+            <a:r>
+              <a:rPr sz="1000" b="0">
+                <a:solidFill>
+                  <a:srgbClr val="0D3B66"/>
+                </a:solidFill>
+                <a:latin typeface="Calibri"/>
+              </a:rPr>
+              <a:t>• Anillo Plaza (000025-12): umbral diario 22 m³/día (promedio ~17 × 1,25). Julio tuvo un pico de 58; agosto bajó a ~13. Avisa si se reabre esa alza.</a:t>
+            </a:r>
+          </a:p>
+        </p:txBody>
+      </p:sp>
+      <p:sp>
+        <p:nvSpPr>
+          <p:cNvPr id="23" name="Rounded Rectangle 22"/>
+          <p:cNvSpPr/>
+          <p:nvPr/>
+        </p:nvSpPr>
+        <p:spPr>
+          <a:xfrm>
+            <a:off x="228600" y="6016752"/>
+            <a:ext cx="11704320" cy="731520"/>
           </a:xfrm>
           <a:prstGeom prst="roundRect">
             <a:avLst>
@@ -11113,13 +12903,13 @@
       </p:sp>
       <p:sp>
         <p:nvSpPr>
-          <p:cNvPr id="21" name="TextBox 20"/>
+          <p:cNvPr id="24" name="TextBox 23"/>
           <p:cNvSpPr txBox="1"/>
           <p:nvPr/>
         </p:nvSpPr>
         <p:spPr>
           <a:xfrm>
-            <a:off x="347472" y="5486400"/>
+            <a:off x="347472" y="6035040"/>
             <a:ext cx="11430000" cy="256032"/>
           </a:xfrm>
           <a:prstGeom prst="rect">
@@ -11152,14 +12942,14 @@
       </p:sp>
       <p:sp>
         <p:nvSpPr>
-          <p:cNvPr id="22" name="TextBox 21"/>
+          <p:cNvPr id="25" name="TextBox 24"/>
           <p:cNvSpPr txBox="1"/>
           <p:nvPr/>
         </p:nvSpPr>
         <p:spPr>
           <a:xfrm>
-            <a:off x="347472" y="5742432"/>
-            <a:ext cx="11430000" cy="896112"/>
+            <a:off x="347472" y="6272784"/>
+            <a:ext cx="11430000" cy="438912"/>
           </a:xfrm>
           <a:prstGeom prst="rect">
             <a:avLst/>
@@ -11178,7 +12968,7 @@
               </a:spcAft>
             </a:pPr>
             <a:r>
-              <a:rPr sz="1100" b="0">
+              <a:rPr sz="1000" b="0">
                 <a:solidFill>
                   <a:srgbClr val="0D3B66"/>
                 </a:solidFill>
@@ -11194,7 +12984,7 @@
               </a:spcAft>
             </a:pPr>
             <a:r>
-              <a:rPr sz="1100" b="0">
+              <a:rPr sz="1000" b="0">
                 <a:solidFill>
                   <a:srgbClr val="0D3B66"/>
                 </a:solidFill>
@@ -11420,7 +13210,7 @@
         <p:spPr>
           <a:xfrm>
             <a:off x="228600" y="1024128"/>
-            <a:ext cx="3977639" cy="2331720"/>
+            <a:ext cx="3977639" cy="2212848"/>
           </a:xfrm>
           <a:prstGeom prst="roundRect">
             <a:avLst>
@@ -11464,7 +13254,7 @@
         </p:nvSpPr>
         <p:spPr>
           <a:xfrm>
-            <a:off x="347472" y="1078992"/>
+            <a:off x="347472" y="1060704"/>
             <a:ext cx="3749039" cy="256032"/>
           </a:xfrm>
           <a:prstGeom prst="rect">
@@ -11503,8 +13293,8 @@
         </p:nvSpPr>
         <p:spPr>
           <a:xfrm>
-            <a:off x="347472" y="1353312"/>
-            <a:ext cx="3749039" cy="1920240"/>
+            <a:off x="347472" y="1316736"/>
+            <a:ext cx="3749039" cy="1847088"/>
           </a:xfrm>
           <a:prstGeom prst="rect">
             <a:avLst/>
@@ -11559,7 +13349,7 @@
         <p:spPr>
           <a:xfrm>
             <a:off x="4297680" y="1024128"/>
-            <a:ext cx="7635240" cy="2331720"/>
+            <a:ext cx="7635240" cy="2212848"/>
           </a:xfrm>
           <a:prstGeom prst="roundRect">
             <a:avLst>
@@ -11603,7 +13393,7 @@
         </p:nvSpPr>
         <p:spPr>
           <a:xfrm>
-            <a:off x="4434840" y="1078992"/>
+            <a:off x="4434840" y="1060704"/>
             <a:ext cx="3657600" cy="256032"/>
           </a:xfrm>
           <a:prstGeom prst="rect">
@@ -11642,8 +13432,8 @@
         </p:nvSpPr>
         <p:spPr>
           <a:xfrm>
-            <a:off x="4434840" y="1353312"/>
-            <a:ext cx="3611880" cy="1920240"/>
+            <a:off x="4434840" y="1316736"/>
+            <a:ext cx="3611880" cy="1847088"/>
           </a:xfrm>
           <a:prstGeom prst="rect">
             <a:avLst/>
@@ -11769,7 +13559,7 @@
         </p:blipFill>
         <p:spPr>
           <a:xfrm>
-            <a:off x="8138160" y="1325880"/>
+            <a:off x="8138160" y="1280160"/>
             <a:ext cx="3611880" cy="1488617"/>
           </a:xfrm>
           <a:prstGeom prst="rect">
@@ -11785,8 +13575,8 @@
         </p:nvSpPr>
         <p:spPr>
           <a:xfrm>
-            <a:off x="228600" y="3456432"/>
-            <a:ext cx="5852160" cy="1874519"/>
+            <a:off x="228600" y="3310128"/>
+            <a:ext cx="5852160" cy="1444752"/>
           </a:xfrm>
           <a:prstGeom prst="roundRect">
             <a:avLst>
@@ -11830,7 +13620,7 @@
         </p:nvSpPr>
         <p:spPr>
           <a:xfrm>
-            <a:off x="347472" y="3511296"/>
+            <a:off x="347472" y="3346704"/>
             <a:ext cx="5577840" cy="256032"/>
           </a:xfrm>
           <a:prstGeom prst="rect">
@@ -11869,8 +13659,8 @@
         </p:nvSpPr>
         <p:spPr>
           <a:xfrm>
-            <a:off x="347472" y="3785615"/>
-            <a:ext cx="5596128" cy="1481328"/>
+            <a:off x="347472" y="3602736"/>
+            <a:ext cx="5596128" cy="1097280"/>
           </a:xfrm>
           <a:prstGeom prst="rect">
             <a:avLst/>
@@ -11889,7 +13679,7 @@
               </a:spcAft>
             </a:pPr>
             <a:r>
-              <a:rPr sz="1000" b="0">
+              <a:rPr sz="900" b="0">
                 <a:solidFill>
                   <a:srgbClr val="0D3B66"/>
                 </a:solidFill>
@@ -11905,7 +13695,7 @@
               </a:spcAft>
             </a:pPr>
             <a:r>
-              <a:rPr sz="1000" b="0">
+              <a:rPr sz="900" b="0">
                 <a:solidFill>
                   <a:srgbClr val="0D3B66"/>
                 </a:solidFill>
@@ -11921,7 +13711,7 @@
               </a:spcAft>
             </a:pPr>
             <a:r>
-              <a:rPr sz="1000" b="0">
+              <a:rPr sz="900" b="0">
                 <a:solidFill>
                   <a:srgbClr val="0D3B66"/>
                 </a:solidFill>
@@ -11937,7 +13727,7 @@
               </a:spcAft>
             </a:pPr>
             <a:r>
-              <a:rPr sz="1000" b="0">
+              <a:rPr sz="900" b="0">
                 <a:solidFill>
                   <a:srgbClr val="0D3B66"/>
                 </a:solidFill>
@@ -11956,8 +13746,8 @@
         </p:nvSpPr>
         <p:spPr>
           <a:xfrm>
-            <a:off x="6217920" y="3456432"/>
-            <a:ext cx="5715000" cy="1874519"/>
+            <a:off x="6217920" y="3310128"/>
+            <a:ext cx="5715000" cy="1444752"/>
           </a:xfrm>
           <a:prstGeom prst="roundRect">
             <a:avLst>
@@ -12001,7 +13791,7 @@
         </p:nvSpPr>
         <p:spPr>
           <a:xfrm>
-            <a:off x="6336792" y="3511296"/>
+            <a:off x="6336792" y="3346704"/>
             <a:ext cx="5486400" cy="256032"/>
           </a:xfrm>
           <a:prstGeom prst="rect">
@@ -12040,8 +13830,8 @@
         </p:nvSpPr>
         <p:spPr>
           <a:xfrm>
-            <a:off x="6336792" y="3785615"/>
-            <a:ext cx="5468112" cy="1481328"/>
+            <a:off x="6336792" y="3602736"/>
+            <a:ext cx="5468112" cy="1097280"/>
           </a:xfrm>
           <a:prstGeom prst="rect">
             <a:avLst/>
@@ -12060,7 +13850,7 @@
               </a:spcAft>
             </a:pPr>
             <a:r>
-              <a:rPr sz="1000" b="0">
+              <a:rPr sz="900" b="0">
                 <a:solidFill>
                   <a:srgbClr val="0D3B66"/>
                 </a:solidFill>
@@ -12076,7 +13866,7 @@
               </a:spcAft>
             </a:pPr>
             <a:r>
-              <a:rPr sz="1000" b="0">
+              <a:rPr sz="900" b="0">
                 <a:solidFill>
                   <a:srgbClr val="0D3B66"/>
                 </a:solidFill>
@@ -12092,7 +13882,7 @@
               </a:spcAft>
             </a:pPr>
             <a:r>
-              <a:rPr sz="1000" b="0">
+              <a:rPr sz="900" b="0">
                 <a:solidFill>
                   <a:srgbClr val="0D3B66"/>
                 </a:solidFill>
@@ -12111,8 +13901,149 @@
         </p:nvSpPr>
         <p:spPr>
           <a:xfrm>
-            <a:off x="228600" y="5440680"/>
-            <a:ext cx="11704320" cy="1261872"/>
+            <a:off x="228600" y="4828032"/>
+            <a:ext cx="11704320" cy="1115568"/>
+          </a:xfrm>
+          <a:prstGeom prst="roundRect">
+            <a:avLst>
+              <a:gd name="adj" fmla="val 8000"/>
+            </a:avLst>
+          </a:prstGeom>
+          <a:solidFill>
+            <a:srgbClr val="E8F4F8"/>
+          </a:solidFill>
+          <a:ln w="6350">
+            <a:solidFill>
+              <a:srgbClr val="1F77B4"/>
+            </a:solidFill>
+          </a:ln>
+        </p:spPr>
+        <p:style>
+          <a:lnRef idx="1">
+            <a:schemeClr val="accent1"/>
+          </a:lnRef>
+          <a:fillRef idx="3">
+            <a:schemeClr val="accent1"/>
+          </a:fillRef>
+          <a:effectRef idx="2">
+            <a:schemeClr val="accent1"/>
+          </a:effectRef>
+          <a:fontRef idx="minor">
+            <a:schemeClr val="lt1"/>
+          </a:fontRef>
+        </p:style>
+        <p:txBody>
+          <a:bodyPr rtlCol="0" anchor="ctr"/>
+          <a:lstStyle/>
+          <a:p>
+            <a:pPr algn="ctr"/>
+          </a:p>
+        </p:txBody>
+      </p:sp>
+      <p:sp>
+        <p:nvSpPr>
+          <p:cNvPr id="21" name="TextBox 20"/>
+          <p:cNvSpPr txBox="1"/>
+          <p:nvPr/>
+        </p:nvSpPr>
+        <p:spPr>
+          <a:xfrm>
+            <a:off x="347472" y="4864608"/>
+            <a:ext cx="11430000" cy="256032"/>
+          </a:xfrm>
+          <a:prstGeom prst="rect">
+            <a:avLst/>
+          </a:prstGeom>
+          <a:noFill/>
+        </p:spPr>
+        <p:txBody>
+          <a:bodyPr wrap="square">
+            <a:spAutoFit/>
+          </a:bodyPr>
+          <a:lstStyle/>
+          <a:p>
+            <a:pPr algn="l">
+              <a:spcAft>
+                <a:spcPts val="200"/>
+              </a:spcAft>
+            </a:pPr>
+            <a:r>
+              <a:rPr sz="1100" b="1">
+                <a:solidFill>
+                  <a:srgbClr val="1F77B4"/>
+                </a:solidFill>
+                <a:latin typeface="Calibri"/>
+              </a:rPr>
+              <a:t>6. ALERTAS DE UMBRAL — PROPONER EN LA REUNIÓN</a:t>
+            </a:r>
+          </a:p>
+        </p:txBody>
+      </p:sp>
+      <p:sp>
+        <p:nvSpPr>
+          <p:cNvPr id="22" name="TextBox 21"/>
+          <p:cNvSpPr txBox="1"/>
+          <p:nvPr/>
+        </p:nvSpPr>
+        <p:spPr>
+          <a:xfrm>
+            <a:off x="347472" y="5120640"/>
+            <a:ext cx="11430000" cy="768096"/>
+          </a:xfrm>
+          <a:prstGeom prst="rect">
+            <a:avLst/>
+          </a:prstGeom>
+          <a:noFill/>
+        </p:spPr>
+        <p:txBody>
+          <a:bodyPr wrap="square">
+            <a:spAutoFit/>
+          </a:bodyPr>
+          <a:lstStyle/>
+          <a:p>
+            <a:pPr algn="l">
+              <a:spcAft>
+                <a:spcPts val="200"/>
+              </a:spcAft>
+            </a:pPr>
+            <a:r>
+              <a:rPr sz="1000" b="0">
+                <a:solidFill>
+                  <a:srgbClr val="0D3B66"/>
+                </a:solidFill>
+                <a:latin typeface="Calibri"/>
+              </a:rPr>
+              <a:t>• Anillo Sur (000025-37): umbral diario 14 m³/día (promedio ~11 × 1,25). Recinto estable; es el anillo de mayor volumen.</a:t>
+            </a:r>
+          </a:p>
+          <a:p>
+            <a:pPr algn="l">
+              <a:spcAft>
+                <a:spcPts val="200"/>
+              </a:spcAft>
+            </a:pPr>
+            <a:r>
+              <a:rPr sz="1000" b="0">
+                <a:solidFill>
+                  <a:srgbClr val="0D3B66"/>
+                </a:solidFill>
+                <a:latin typeface="Calibri"/>
+              </a:rPr>
+              <a:t>• Anillo Norte (000025-38): umbral diario 13 m³/día (promedio ~10 × 1,25). Los dos anillos cubren el mall; no hay un tercer punto que priorizar.</a:t>
+            </a:r>
+          </a:p>
+        </p:txBody>
+      </p:sp>
+      <p:sp>
+        <p:nvSpPr>
+          <p:cNvPr id="23" name="Rounded Rectangle 22"/>
+          <p:cNvSpPr/>
+          <p:nvPr/>
+        </p:nvSpPr>
+        <p:spPr>
+          <a:xfrm>
+            <a:off x="228600" y="6016752"/>
+            <a:ext cx="11704320" cy="731520"/>
           </a:xfrm>
           <a:prstGeom prst="roundRect">
             <a:avLst>
@@ -12152,13 +14083,13 @@
       </p:sp>
       <p:sp>
         <p:nvSpPr>
-          <p:cNvPr id="21" name="TextBox 20"/>
+          <p:cNvPr id="24" name="TextBox 23"/>
           <p:cNvSpPr txBox="1"/>
           <p:nvPr/>
         </p:nvSpPr>
         <p:spPr>
           <a:xfrm>
-            <a:off x="347472" y="5486400"/>
+            <a:off x="347472" y="6035040"/>
             <a:ext cx="11430000" cy="256032"/>
           </a:xfrm>
           <a:prstGeom prst="rect">
@@ -12191,14 +14122,14 @@
       </p:sp>
       <p:sp>
         <p:nvSpPr>
-          <p:cNvPr id="22" name="TextBox 21"/>
+          <p:cNvPr id="25" name="TextBox 24"/>
           <p:cNvSpPr txBox="1"/>
           <p:nvPr/>
         </p:nvSpPr>
         <p:spPr>
           <a:xfrm>
-            <a:off x="347472" y="5742432"/>
-            <a:ext cx="11430000" cy="896112"/>
+            <a:off x="347472" y="6272784"/>
+            <a:ext cx="11430000" cy="438912"/>
           </a:xfrm>
           <a:prstGeom prst="rect">
             <a:avLst/>
@@ -12217,7 +14148,7 @@
               </a:spcAft>
             </a:pPr>
             <a:r>
-              <a:rPr sz="1100" b="0">
+              <a:rPr sz="1000" b="0">
                 <a:solidFill>
                   <a:srgbClr val="0D3B66"/>
                 </a:solidFill>
@@ -12233,7 +14164,7 @@
               </a:spcAft>
             </a:pPr>
             <a:r>
-              <a:rPr sz="1100" b="0">
+              <a:rPr sz="1000" b="0">
                 <a:solidFill>
                   <a:srgbClr val="0D3B66"/>
                 </a:solidFill>
@@ -12459,7 +14390,7 @@
         <p:spPr>
           <a:xfrm>
             <a:off x="228600" y="1024128"/>
-            <a:ext cx="3977639" cy="2331720"/>
+            <a:ext cx="3977639" cy="2212848"/>
           </a:xfrm>
           <a:prstGeom prst="roundRect">
             <a:avLst>
@@ -12503,7 +14434,7 @@
         </p:nvSpPr>
         <p:spPr>
           <a:xfrm>
-            <a:off x="347472" y="1078992"/>
+            <a:off x="347472" y="1060704"/>
             <a:ext cx="3749039" cy="256032"/>
           </a:xfrm>
           <a:prstGeom prst="rect">
@@ -12542,8 +14473,8 @@
         </p:nvSpPr>
         <p:spPr>
           <a:xfrm>
-            <a:off x="347472" y="1353312"/>
-            <a:ext cx="3749039" cy="1920240"/>
+            <a:off x="347472" y="1316736"/>
+            <a:ext cx="3749039" cy="1847088"/>
           </a:xfrm>
           <a:prstGeom prst="rect">
             <a:avLst/>
@@ -12726,7 +14657,7 @@
         <p:spPr>
           <a:xfrm>
             <a:off x="4297680" y="1024128"/>
-            <a:ext cx="7635240" cy="2331720"/>
+            <a:ext cx="7635240" cy="2212848"/>
           </a:xfrm>
           <a:prstGeom prst="roundRect">
             <a:avLst>
@@ -12770,7 +14701,7 @@
         </p:nvSpPr>
         <p:spPr>
           <a:xfrm>
-            <a:off x="4434840" y="1078992"/>
+            <a:off x="4434840" y="1060704"/>
             <a:ext cx="3657600" cy="256032"/>
           </a:xfrm>
           <a:prstGeom prst="rect">
@@ -12809,8 +14740,8 @@
         </p:nvSpPr>
         <p:spPr>
           <a:xfrm>
-            <a:off x="4434840" y="1353312"/>
-            <a:ext cx="3611880" cy="1920240"/>
+            <a:off x="4434840" y="1316736"/>
+            <a:ext cx="3611880" cy="1847088"/>
           </a:xfrm>
           <a:prstGeom prst="rect">
             <a:avLst/>
@@ -12952,7 +14883,7 @@
         </p:blipFill>
         <p:spPr>
           <a:xfrm>
-            <a:off x="8138160" y="1325880"/>
+            <a:off x="8138160" y="1280160"/>
             <a:ext cx="3611880" cy="1488617"/>
           </a:xfrm>
           <a:prstGeom prst="rect">
@@ -12968,8 +14899,8 @@
         </p:nvSpPr>
         <p:spPr>
           <a:xfrm>
-            <a:off x="228600" y="3456432"/>
-            <a:ext cx="5852160" cy="1874519"/>
+            <a:off x="228600" y="3310128"/>
+            <a:ext cx="5852160" cy="1444752"/>
           </a:xfrm>
           <a:prstGeom prst="roundRect">
             <a:avLst>
@@ -13013,7 +14944,7 @@
         </p:nvSpPr>
         <p:spPr>
           <a:xfrm>
-            <a:off x="347472" y="3511296"/>
+            <a:off x="347472" y="3346704"/>
             <a:ext cx="5577840" cy="256032"/>
           </a:xfrm>
           <a:prstGeom prst="rect">
@@ -13052,8 +14983,8 @@
         </p:nvSpPr>
         <p:spPr>
           <a:xfrm>
-            <a:off x="347472" y="3785615"/>
-            <a:ext cx="5596128" cy="1481328"/>
+            <a:off x="347472" y="3602736"/>
+            <a:ext cx="5596128" cy="1097280"/>
           </a:xfrm>
           <a:prstGeom prst="rect">
             <a:avLst/>
@@ -13072,7 +15003,7 @@
               </a:spcAft>
             </a:pPr>
             <a:r>
-              <a:rPr sz="1000" b="0">
+              <a:rPr sz="900" b="0">
                 <a:solidFill>
                   <a:srgbClr val="0D3B66"/>
                 </a:solidFill>
@@ -13088,7 +15019,7 @@
               </a:spcAft>
             </a:pPr>
             <a:r>
-              <a:rPr sz="1000" b="0">
+              <a:rPr sz="900" b="0">
                 <a:solidFill>
                   <a:srgbClr val="0D3B66"/>
                 </a:solidFill>
@@ -13104,7 +15035,7 @@
               </a:spcAft>
             </a:pPr>
             <a:r>
-              <a:rPr sz="1000" b="0">
+              <a:rPr sz="900" b="0">
                 <a:solidFill>
                   <a:srgbClr val="0D3B66"/>
                 </a:solidFill>
@@ -13120,29 +15051,13 @@
               </a:spcAft>
             </a:pPr>
             <a:r>
-              <a:rPr sz="1000" b="0">
+              <a:rPr sz="900" b="0">
                 <a:solidFill>
                   <a:srgbClr val="0D3B66"/>
                 </a:solidFill>
                 <a:latin typeface="Calibri"/>
               </a:rPr>
               <a:t>• 10/08 DL: 41,2 m³ en 0–6 h (de 221 m³ del día). El deck ya marcaba al DL como el mayor nocturno de la cadena.</a:t>
-            </a:r>
-          </a:p>
-          <a:p>
-            <a:pPr algn="l">
-              <a:spcAft>
-                <a:spcPts val="200"/>
-              </a:spcAft>
-            </a:pPr>
-            <a:r>
-              <a:rPr sz="1000" b="0">
-                <a:solidFill>
-                  <a:srgbClr val="0D3B66"/>
-                </a:solidFill>
-                <a:latin typeface="Calibri"/>
-              </a:rPr>
-              <a:t>• Andén Locales Gastronómicos (21) sube: jun 3.006,5 → jul 4.583,2 m³. Piletas: volumen menor.</a:t>
             </a:r>
           </a:p>
         </p:txBody>
@@ -13155,8 +15070,8 @@
         </p:nvSpPr>
         <p:spPr>
           <a:xfrm>
-            <a:off x="6217920" y="3456432"/>
-            <a:ext cx="5715000" cy="1874519"/>
+            <a:off x="6217920" y="3310128"/>
+            <a:ext cx="5715000" cy="1444752"/>
           </a:xfrm>
           <a:prstGeom prst="roundRect">
             <a:avLst>
@@ -13200,7 +15115,7 @@
         </p:nvSpPr>
         <p:spPr>
           <a:xfrm>
-            <a:off x="6336792" y="3511296"/>
+            <a:off x="6336792" y="3346704"/>
             <a:ext cx="5486400" cy="256032"/>
           </a:xfrm>
           <a:prstGeom prst="rect">
@@ -13239,8 +15154,8 @@
         </p:nvSpPr>
         <p:spPr>
           <a:xfrm>
-            <a:off x="6336792" y="3785615"/>
-            <a:ext cx="5468112" cy="1481328"/>
+            <a:off x="6336792" y="3602736"/>
+            <a:ext cx="5468112" cy="1097280"/>
           </a:xfrm>
           <a:prstGeom prst="rect">
             <a:avLst/>
@@ -13259,7 +15174,7 @@
               </a:spcAft>
             </a:pPr>
             <a:r>
-              <a:rPr sz="1000" b="0">
+              <a:rPr sz="900" b="0">
                 <a:solidFill>
                   <a:srgbClr val="0D3B66"/>
                 </a:solidFill>
@@ -13275,7 +15190,7 @@
               </a:spcAft>
             </a:pPr>
             <a:r>
-              <a:rPr sz="1000" b="0">
+              <a:rPr sz="900" b="0">
                 <a:solidFill>
                   <a:srgbClr val="0D3B66"/>
                 </a:solidFill>
@@ -13291,7 +15206,7 @@
               </a:spcAft>
             </a:pPr>
             <a:r>
-              <a:rPr sz="1000" b="0">
+              <a:rPr sz="900" b="0">
                 <a:solidFill>
                   <a:srgbClr val="0D3B66"/>
                 </a:solidFill>
@@ -13310,8 +15225,149 @@
         </p:nvSpPr>
         <p:spPr>
           <a:xfrm>
-            <a:off x="228600" y="5440680"/>
-            <a:ext cx="11704320" cy="1261872"/>
+            <a:off x="228600" y="4828032"/>
+            <a:ext cx="11704320" cy="1115568"/>
+          </a:xfrm>
+          <a:prstGeom prst="roundRect">
+            <a:avLst>
+              <a:gd name="adj" fmla="val 8000"/>
+            </a:avLst>
+          </a:prstGeom>
+          <a:solidFill>
+            <a:srgbClr val="E8F4F8"/>
+          </a:solidFill>
+          <a:ln w="6350">
+            <a:solidFill>
+              <a:srgbClr val="1F77B4"/>
+            </a:solidFill>
+          </a:ln>
+        </p:spPr>
+        <p:style>
+          <a:lnRef idx="1">
+            <a:schemeClr val="accent1"/>
+          </a:lnRef>
+          <a:fillRef idx="3">
+            <a:schemeClr val="accent1"/>
+          </a:fillRef>
+          <a:effectRef idx="2">
+            <a:schemeClr val="accent1"/>
+          </a:effectRef>
+          <a:fontRef idx="minor">
+            <a:schemeClr val="lt1"/>
+          </a:fontRef>
+        </p:style>
+        <p:txBody>
+          <a:bodyPr rtlCol="0" anchor="ctr"/>
+          <a:lstStyle/>
+          <a:p>
+            <a:pPr algn="ctr"/>
+          </a:p>
+        </p:txBody>
+      </p:sp>
+      <p:sp>
+        <p:nvSpPr>
+          <p:cNvPr id="21" name="TextBox 20"/>
+          <p:cNvSpPr txBox="1"/>
+          <p:nvPr/>
+        </p:nvSpPr>
+        <p:spPr>
+          <a:xfrm>
+            <a:off x="347472" y="4864608"/>
+            <a:ext cx="11430000" cy="256032"/>
+          </a:xfrm>
+          <a:prstGeom prst="rect">
+            <a:avLst/>
+          </a:prstGeom>
+          <a:noFill/>
+        </p:spPr>
+        <p:txBody>
+          <a:bodyPr wrap="square">
+            <a:spAutoFit/>
+          </a:bodyPr>
+          <a:lstStyle/>
+          <a:p>
+            <a:pPr algn="l">
+              <a:spcAft>
+                <a:spcPts val="200"/>
+              </a:spcAft>
+            </a:pPr>
+            <a:r>
+              <a:rPr sz="1100" b="1">
+                <a:solidFill>
+                  <a:srgbClr val="1F77B4"/>
+                </a:solidFill>
+                <a:latin typeface="Calibri"/>
+              </a:rPr>
+              <a:t>6. ALERTAS DE UMBRAL — PROPONER EN LA REUNIÓN</a:t>
+            </a:r>
+          </a:p>
+        </p:txBody>
+      </p:sp>
+      <p:sp>
+        <p:nvSpPr>
+          <p:cNvPr id="22" name="TextBox 21"/>
+          <p:cNvSpPr txBox="1"/>
+          <p:nvPr/>
+        </p:nvSpPr>
+        <p:spPr>
+          <a:xfrm>
+            <a:off x="347472" y="5120640"/>
+            <a:ext cx="11430000" cy="768096"/>
+          </a:xfrm>
+          <a:prstGeom prst="rect">
+            <a:avLst/>
+          </a:prstGeom>
+          <a:noFill/>
+        </p:spPr>
+        <p:txBody>
+          <a:bodyPr wrap="square">
+            <a:spAutoFit/>
+          </a:bodyPr>
+          <a:lstStyle/>
+          <a:p>
+            <a:pPr algn="l">
+              <a:spcAft>
+                <a:spcPts val="200"/>
+              </a:spcAft>
+            </a:pPr>
+            <a:r>
+              <a:rPr sz="1000" b="0">
+                <a:solidFill>
+                  <a:srgbClr val="0D3B66"/>
+                </a:solidFill>
+                <a:latin typeface="Calibri"/>
+              </a:rPr>
+              <a:t>• Distrito de Lujo (000025-27) — nocturno: alerta si 00:00–06:00 &gt; 15 m³ (el 10/08 = 41 m³). Es el mayor impacto de madrugada de Kennedy.</a:t>
+            </a:r>
+          </a:p>
+          <a:p>
+            <a:pPr algn="l">
+              <a:spcAft>
+                <a:spcPts val="200"/>
+              </a:spcAft>
+            </a:pPr>
+            <a:r>
+              <a:rPr sz="1000" b="0">
+                <a:solidFill>
+                  <a:srgbClr val="0D3B66"/>
+                </a:solidFill>
+                <a:latin typeface="Calibri"/>
+              </a:rPr>
+              <a:t>• Andén Locales Gastronómicos (000025-21): umbral diario 180 m³/día (promedio ~144 × 1,25). Agosto ~219: confirma el alza. No umbral en Sandía: es bomba de la cadena DL.</a:t>
+            </a:r>
+          </a:p>
+        </p:txBody>
+      </p:sp>
+      <p:sp>
+        <p:nvSpPr>
+          <p:cNvPr id="23" name="Rounded Rectangle 22"/>
+          <p:cNvSpPr/>
+          <p:nvPr/>
+        </p:nvSpPr>
+        <p:spPr>
+          <a:xfrm>
+            <a:off x="228600" y="6016752"/>
+            <a:ext cx="11704320" cy="731520"/>
           </a:xfrm>
           <a:prstGeom prst="roundRect">
             <a:avLst>
@@ -13351,13 +15407,13 @@
       </p:sp>
       <p:sp>
         <p:nvSpPr>
-          <p:cNvPr id="21" name="TextBox 20"/>
+          <p:cNvPr id="24" name="TextBox 23"/>
           <p:cNvSpPr txBox="1"/>
           <p:nvPr/>
         </p:nvSpPr>
         <p:spPr>
           <a:xfrm>
-            <a:off x="347472" y="5486400"/>
+            <a:off x="347472" y="6035040"/>
             <a:ext cx="11430000" cy="256032"/>
           </a:xfrm>
           <a:prstGeom prst="rect">
@@ -13390,14 +15446,14 @@
       </p:sp>
       <p:sp>
         <p:nvSpPr>
-          <p:cNvPr id="22" name="TextBox 21"/>
+          <p:cNvPr id="25" name="TextBox 24"/>
           <p:cNvSpPr txBox="1"/>
           <p:nvPr/>
         </p:nvSpPr>
         <p:spPr>
           <a:xfrm>
-            <a:off x="347472" y="5742432"/>
-            <a:ext cx="11430000" cy="896112"/>
+            <a:off x="347472" y="6272784"/>
+            <a:ext cx="11430000" cy="438912"/>
           </a:xfrm>
           <a:prstGeom prst="rect">
             <a:avLst/>
@@ -13416,7 +15472,7 @@
               </a:spcAft>
             </a:pPr>
             <a:r>
-              <a:rPr sz="1100" b="0">
+              <a:rPr sz="1000" b="0">
                 <a:solidFill>
                   <a:srgbClr val="0D3B66"/>
                 </a:solidFill>
@@ -13432,7 +15488,7 @@
               </a:spcAft>
             </a:pPr>
             <a:r>
-              <a:rPr sz="1100" b="0">
+              <a:rPr sz="1000" b="0">
                 <a:solidFill>
                   <a:srgbClr val="0D3B66"/>
                 </a:solidFill>

</xml_diff>